<commit_message>
Update presentation content and structure for NLP introduction. Changed title, company, and subject details. Enhanced slide content to cover NLP concepts, challenges, and applications, while adjusting layout and formatting for clarity.
</commit_message>
<xml_diff>
--- a/Office-Presentation-English.pptx
+++ b/Office-Presentation-English.pptx
@@ -10,9 +10,12 @@
     <p:sldId id="258" r:id="rId4"/>
     <p:sldId id="259" r:id="rId5"/>
     <p:sldId id="260" r:id="rId6"/>
+    <p:sldId id="261" r:id="rId7"/>
+    <p:sldId id="262" r:id="rId8"/>
+    <p:sldId id="263" r:id="rId9"/>
   </p:sldIdLst>
   <p:notesMasterIdLst>
-    <p:notesMasterId r:id="rId7"/>
+    <p:notesMasterId r:id="rId10"/>
   </p:notesMasterIdLst>
   <p:sldSz cx="12192000" cy="6858000"/>
   <p:notesSz cx="6858000" cy="12192000"/>
@@ -882,6 +885,270 @@
             <a:fld id="{F7021451-1387-4CA6-816F-3879F97B5CBC}" type="slidenum">
               <a:rPr lang="en-US"/>
               <a:t>5</a:t>
+            </a:fld>
+            <a:endParaRPr lang="en-US"/>
+          </a:p>
+        </p:txBody>
+      </p:sp>
+    </p:spTree>
+    <p:extLst>
+      <p:ext uri="{BB962C8B-B14F-4D97-AF65-F5344CB8AC3E}">
+        <p14:creationId xmlns:p14="http://schemas.microsoft.com/office/powerpoint/2010/main" val="1024086991"/>
+      </p:ext>
+    </p:extLst>
+  </p:cSld>
+  <p:clrMapOvr>
+    <a:masterClrMapping/>
+  </p:clrMapOvr>
+</p:notes>
+</file>
+
+<file path=ppt/notesSlides/notesSlide6.xml><?xml version="1.0" encoding="utf-8"?>
+<p:notes xmlns:a="http://schemas.openxmlformats.org/drawingml/2006/main" xmlns:r="http://schemas.openxmlformats.org/officeDocument/2006/relationships" xmlns:p="http://schemas.openxmlformats.org/presentationml/2006/main">
+  <p:cSld>
+    <p:spTree>
+      <p:nvGrpSpPr>
+        <p:cNvPr id="1" name=""/>
+        <p:cNvGrpSpPr/>
+        <p:nvPr/>
+      </p:nvGrpSpPr>
+      <p:grpSpPr>
+        <a:xfrm>
+          <a:off x="0" y="0"/>
+          <a:ext cx="0" cy="0"/>
+          <a:chOff x="0" y="0"/>
+          <a:chExt cx="0" cy="0"/>
+        </a:xfrm>
+      </p:grpSpPr>
+      <p:sp>
+        <p:nvSpPr>
+          <p:cNvPr id="2" name="Slide Image Placeholder 1"/>
+          <p:cNvSpPr>
+            <a:spLocks noGrp="1" noRot="1" noChangeAspect="1"/>
+          </p:cNvSpPr>
+          <p:nvPr>
+            <p:ph type="sldImg"/>
+          </p:nvPr>
+        </p:nvSpPr>
+        <p:spPr/>
+      </p:sp>
+      <p:sp>
+        <p:nvSpPr>
+          <p:cNvPr id="3" name="Notes Placeholder 2"/>
+          <p:cNvSpPr>
+            <a:spLocks noGrp="1"/>
+          </p:cNvSpPr>
+          <p:nvPr>
+            <p:ph type="body" idx="1"/>
+          </p:nvPr>
+        </p:nvSpPr>
+        <p:spPr/>
+        <p:txBody>
+          <a:bodyPr/>
+          <a:lstStyle/>
+          <a:p>
+            <a:r>
+              <a:rPr lang="en-US" dirty="0"/>
+              <a:t/>
+            </a:r>
+            <a:endParaRPr lang="en-US" dirty="0"/>
+          </a:p>
+        </p:txBody>
+      </p:sp>
+      <p:sp>
+        <p:nvSpPr>
+          <p:cNvPr id="4" name="Slide Number Placeholder 3"/>
+          <p:cNvSpPr>
+            <a:spLocks noGrp="1"/>
+          </p:cNvSpPr>
+          <p:nvPr>
+            <p:ph type="sldNum" sz="quarter" idx="10"/>
+          </p:nvPr>
+        </p:nvSpPr>
+        <p:spPr/>
+        <p:txBody>
+          <a:bodyPr/>
+          <a:lstStyle/>
+          <a:p>
+            <a:fld id="{F7021451-1387-4CA6-816F-3879F97B5CBC}" type="slidenum">
+              <a:rPr lang="en-US"/>
+              <a:t>6</a:t>
+            </a:fld>
+            <a:endParaRPr lang="en-US"/>
+          </a:p>
+        </p:txBody>
+      </p:sp>
+    </p:spTree>
+    <p:extLst>
+      <p:ext uri="{BB962C8B-B14F-4D97-AF65-F5344CB8AC3E}">
+        <p14:creationId xmlns:p14="http://schemas.microsoft.com/office/powerpoint/2010/main" val="1024086991"/>
+      </p:ext>
+    </p:extLst>
+  </p:cSld>
+  <p:clrMapOvr>
+    <a:masterClrMapping/>
+  </p:clrMapOvr>
+</p:notes>
+</file>
+
+<file path=ppt/notesSlides/notesSlide7.xml><?xml version="1.0" encoding="utf-8"?>
+<p:notes xmlns:a="http://schemas.openxmlformats.org/drawingml/2006/main" xmlns:r="http://schemas.openxmlformats.org/officeDocument/2006/relationships" xmlns:p="http://schemas.openxmlformats.org/presentationml/2006/main">
+  <p:cSld>
+    <p:spTree>
+      <p:nvGrpSpPr>
+        <p:cNvPr id="1" name=""/>
+        <p:cNvGrpSpPr/>
+        <p:nvPr/>
+      </p:nvGrpSpPr>
+      <p:grpSpPr>
+        <a:xfrm>
+          <a:off x="0" y="0"/>
+          <a:ext cx="0" cy="0"/>
+          <a:chOff x="0" y="0"/>
+          <a:chExt cx="0" cy="0"/>
+        </a:xfrm>
+      </p:grpSpPr>
+      <p:sp>
+        <p:nvSpPr>
+          <p:cNvPr id="2" name="Slide Image Placeholder 1"/>
+          <p:cNvSpPr>
+            <a:spLocks noGrp="1" noRot="1" noChangeAspect="1"/>
+          </p:cNvSpPr>
+          <p:nvPr>
+            <p:ph type="sldImg"/>
+          </p:nvPr>
+        </p:nvSpPr>
+        <p:spPr/>
+      </p:sp>
+      <p:sp>
+        <p:nvSpPr>
+          <p:cNvPr id="3" name="Notes Placeholder 2"/>
+          <p:cNvSpPr>
+            <a:spLocks noGrp="1"/>
+          </p:cNvSpPr>
+          <p:nvPr>
+            <p:ph type="body" idx="1"/>
+          </p:nvPr>
+        </p:nvSpPr>
+        <p:spPr/>
+        <p:txBody>
+          <a:bodyPr/>
+          <a:lstStyle/>
+          <a:p>
+            <a:r>
+              <a:rPr lang="en-US" dirty="0"/>
+              <a:t/>
+            </a:r>
+            <a:endParaRPr lang="en-US" dirty="0"/>
+          </a:p>
+        </p:txBody>
+      </p:sp>
+      <p:sp>
+        <p:nvSpPr>
+          <p:cNvPr id="4" name="Slide Number Placeholder 3"/>
+          <p:cNvSpPr>
+            <a:spLocks noGrp="1"/>
+          </p:cNvSpPr>
+          <p:nvPr>
+            <p:ph type="sldNum" sz="quarter" idx="10"/>
+          </p:nvPr>
+        </p:nvSpPr>
+        <p:spPr/>
+        <p:txBody>
+          <a:bodyPr/>
+          <a:lstStyle/>
+          <a:p>
+            <a:fld id="{F7021451-1387-4CA6-816F-3879F97B5CBC}" type="slidenum">
+              <a:rPr lang="en-US"/>
+              <a:t>7</a:t>
+            </a:fld>
+            <a:endParaRPr lang="en-US"/>
+          </a:p>
+        </p:txBody>
+      </p:sp>
+    </p:spTree>
+    <p:extLst>
+      <p:ext uri="{BB962C8B-B14F-4D97-AF65-F5344CB8AC3E}">
+        <p14:creationId xmlns:p14="http://schemas.microsoft.com/office/powerpoint/2010/main" val="1024086991"/>
+      </p:ext>
+    </p:extLst>
+  </p:cSld>
+  <p:clrMapOvr>
+    <a:masterClrMapping/>
+  </p:clrMapOvr>
+</p:notes>
+</file>
+
+<file path=ppt/notesSlides/notesSlide8.xml><?xml version="1.0" encoding="utf-8"?>
+<p:notes xmlns:a="http://schemas.openxmlformats.org/drawingml/2006/main" xmlns:r="http://schemas.openxmlformats.org/officeDocument/2006/relationships" xmlns:p="http://schemas.openxmlformats.org/presentationml/2006/main">
+  <p:cSld>
+    <p:spTree>
+      <p:nvGrpSpPr>
+        <p:cNvPr id="1" name=""/>
+        <p:cNvGrpSpPr/>
+        <p:nvPr/>
+      </p:nvGrpSpPr>
+      <p:grpSpPr>
+        <a:xfrm>
+          <a:off x="0" y="0"/>
+          <a:ext cx="0" cy="0"/>
+          <a:chOff x="0" y="0"/>
+          <a:chExt cx="0" cy="0"/>
+        </a:xfrm>
+      </p:grpSpPr>
+      <p:sp>
+        <p:nvSpPr>
+          <p:cNvPr id="2" name="Slide Image Placeholder 1"/>
+          <p:cNvSpPr>
+            <a:spLocks noGrp="1" noRot="1" noChangeAspect="1"/>
+          </p:cNvSpPr>
+          <p:nvPr>
+            <p:ph type="sldImg"/>
+          </p:nvPr>
+        </p:nvSpPr>
+        <p:spPr/>
+      </p:sp>
+      <p:sp>
+        <p:nvSpPr>
+          <p:cNvPr id="3" name="Notes Placeholder 2"/>
+          <p:cNvSpPr>
+            <a:spLocks noGrp="1"/>
+          </p:cNvSpPr>
+          <p:nvPr>
+            <p:ph type="body" idx="1"/>
+          </p:nvPr>
+        </p:nvSpPr>
+        <p:spPr/>
+        <p:txBody>
+          <a:bodyPr/>
+          <a:lstStyle/>
+          <a:p>
+            <a:r>
+              <a:rPr lang="en-US" dirty="0"/>
+              <a:t/>
+            </a:r>
+            <a:endParaRPr lang="en-US" dirty="0"/>
+          </a:p>
+        </p:txBody>
+      </p:sp>
+      <p:sp>
+        <p:nvSpPr>
+          <p:cNvPr id="4" name="Slide Number Placeholder 3"/>
+          <p:cNvSpPr>
+            <a:spLocks noGrp="1"/>
+          </p:cNvSpPr>
+          <p:nvPr>
+            <p:ph type="sldNum" sz="quarter" idx="10"/>
+          </p:nvPr>
+        </p:nvSpPr>
+        <p:spPr/>
+        <p:txBody>
+          <a:bodyPr/>
+          <a:lstStyle/>
+          <a:p>
+            <a:fld id="{F7021451-1387-4CA6-816F-3879F97B5CBC}" type="slidenum">
+              <a:rPr lang="en-US"/>
+              <a:t>8</a:t>
             </a:fld>
             <a:endParaRPr lang="en-US"/>
           </a:p>
@@ -1239,7 +1506,7 @@
         </p:nvSpPr>
         <p:spPr>
           <a:xfrm>
-            <a:off x="731520" y="1920240"/>
+            <a:off x="731520" y="1828800"/>
             <a:ext cx="10789920" cy="731520"/>
           </a:xfrm>
           <a:prstGeom prst="rect">
@@ -1256,14 +1523,14 @@
               <a:buNone/>
             </a:pPr>
             <a:r>
-              <a:rPr lang="en-US" sz="4200" b="1" dirty="0">
+              <a:rPr lang="en-US" sz="4000" b="1" dirty="0">
                 <a:solidFill>
                   <a:srgbClr val="FFFFFF"/>
                 </a:solidFill>
               </a:rPr>
-              <a:t>Welcome to Our Office</a:t>
-            </a:r>
-            <a:endParaRPr lang="en-US" sz="4200" dirty="0"/>
+              <a:t>Day 1: Introduction to NLP</a:t>
+            </a:r>
+            <a:endParaRPr lang="en-US" sz="4000" dirty="0"/>
           </a:p>
         </p:txBody>
       </p:sp>
@@ -1275,8 +1542,8 @@
         </p:nvSpPr>
         <p:spPr>
           <a:xfrm>
-            <a:off x="1005840" y="2926080"/>
-            <a:ext cx="10241280" cy="457200"/>
+            <a:off x="1188720" y="2834640"/>
+            <a:ext cx="9875520" cy="457200"/>
           </a:xfrm>
           <a:prstGeom prst="rect">
             <a:avLst/>
@@ -1297,7 +1564,7 @@
                   <a:srgbClr val="DBEAFE"/>
                 </a:solidFill>
               </a:rPr>
-              <a:t>A quick overview of our workplace, culture, and operations</a:t>
+              <a:t>Theory and practical examples (no coding)</a:t>
             </a:r>
             <a:endParaRPr lang="en-US" sz="1800" dirty="0"/>
           </a:p>
@@ -1311,8 +1578,8 @@
         </p:nvSpPr>
         <p:spPr>
           <a:xfrm>
-            <a:off x="5029200" y="3931920"/>
-            <a:ext cx="2194560" cy="640080"/>
+            <a:off x="4480560" y="3840480"/>
+            <a:ext cx="3200400" cy="640080"/>
           </a:xfrm>
           <a:prstGeom prst="roundRect">
             <a:avLst/>
@@ -1336,8 +1603,8 @@
         </p:nvSpPr>
         <p:spPr>
           <a:xfrm>
-            <a:off x="5029200" y="4096512"/>
-            <a:ext cx="2194560" cy="274320"/>
+            <a:off x="4480560" y="4041648"/>
+            <a:ext cx="3200400" cy="237744"/>
           </a:xfrm>
           <a:prstGeom prst="rect">
             <a:avLst/>
@@ -1353,14 +1620,14 @@
               <a:buNone/>
             </a:pPr>
             <a:r>
-              <a:rPr lang="en-US" sz="1600" b="1" dirty="0">
+              <a:rPr lang="en-US" sz="1400" b="1" dirty="0">
                 <a:solidFill>
                   <a:srgbClr val="FFFFFF"/>
                 </a:solidFill>
               </a:rPr>
-              <a:t>2026</a:t>
-            </a:r>
-            <a:endParaRPr lang="en-US" sz="1600" dirty="0"/>
+              <a:t>Beginner -&gt; Intermediate</a:t>
+            </a:r>
+            <a:endParaRPr lang="en-US" sz="1400" dirty="0"/>
           </a:p>
         </p:txBody>
       </p:sp>
@@ -1430,7 +1697,7 @@
         <p:spPr>
           <a:xfrm>
             <a:off x="548640" y="201168"/>
-            <a:ext cx="7772400" cy="365760"/>
+            <a:ext cx="9601200" cy="365760"/>
           </a:xfrm>
           <a:prstGeom prst="rect">
             <a:avLst/>
@@ -1451,7 +1718,7 @@
                   <a:srgbClr val="FFFFFF"/>
                 </a:solidFill>
               </a:rPr>
-              <a:t>Who We Are</a:t>
+              <a:t>What Is NLP and Why Is It Hard?</a:t>
             </a:r>
             <a:endParaRPr lang="en-US" sz="2000" dirty="0"/>
           </a:p>
@@ -1466,7 +1733,7 @@
         <p:spPr>
           <a:xfrm>
             <a:off x="548640" y="914400"/>
-            <a:ext cx="11155680" cy="365760"/>
+            <a:ext cx="10972800" cy="365760"/>
           </a:xfrm>
           <a:prstGeom prst="rect">
             <a:avLst/>
@@ -1487,7 +1754,7 @@
                   <a:srgbClr val="7F8C8D"/>
                 </a:solidFill>
               </a:rPr>
-              <a:t>Our mission and core values</a:t>
+              <a:t>Core concepts and challenges</a:t>
             </a:r>
             <a:endParaRPr lang="en-US" sz="1300" dirty="0"/>
           </a:p>
@@ -1501,96 +1768,136 @@
         </p:nvSpPr>
         <p:spPr>
           <a:xfrm>
-            <a:off x="731520" y="1645920"/>
-            <a:ext cx="10972800" cy="1463040"/>
-          </a:xfrm>
-          <a:prstGeom prst="rect">
-            <a:avLst/>
-          </a:prstGeom>
-          <a:noFill/>
-          <a:ln/>
-        </p:spPr>
-        <p:txBody>
-          <a:bodyPr wrap="square" rtlCol="0" anchor="t"/>
+            <a:off x="731520" y="1463040"/>
+            <a:ext cx="10972800" cy="640080"/>
+          </a:xfrm>
+          <a:prstGeom prst="rect">
+            <a:avLst/>
+          </a:prstGeom>
+          <a:noFill/>
+          <a:ln/>
+        </p:spPr>
+        <p:txBody>
+          <a:bodyPr wrap="square" rtlCol="0" anchor="ctr"/>
           <a:lstStyle/>
           <a:p>
             <a:pPr indent="0" marL="0">
               <a:buNone/>
             </a:pPr>
             <a:r>
-              <a:rPr lang="en-US" sz="1800" b="1" dirty="0">
+              <a:rPr lang="en-US" sz="1600" dirty="0">
                 <a:solidFill>
                   <a:srgbClr val="1C2833"/>
                 </a:solidFill>
               </a:rPr>
-              <a:t>Mission: </a:t>
-            </a:r>
-            <a:pPr indent="0" marL="0">
-              <a:buNone/>
-            </a:pPr>
-            <a:r>
-              <a:rPr lang="en-US" sz="1800" dirty="0">
-                <a:solidFill>
-                  <a:srgbClr val="334155"/>
-                </a:solidFill>
-              </a:rPr>
-              <a:t>Deliver excellent services with efficiency and integrity.</a:t>
-            </a:r>
-            <a:pPr indent="0" marL="0">
-              <a:buNone/>
-            </a:pPr>
-            <a:endParaRPr lang="en-US" sz="1800" dirty="0"/>
-          </a:p>
-          <a:p>
-            <a:pPr indent="0" marL="0">
-              <a:buNone/>
-            </a:pPr>
-            <a:r>
-              <a:rPr lang="en-US" sz="1800" b="1" dirty="0">
+              <a:t>Natural Language Processing enables computers to understand and generate human language.</a:t>
+            </a:r>
+            <a:endParaRPr lang="en-US" sz="1600" dirty="0"/>
+          </a:p>
+        </p:txBody>
+      </p:sp>
+      <p:sp>
+        <p:nvSpPr>
+          <p:cNvPr id="6" name="Text 4"/>
+          <p:cNvSpPr/>
+          <p:nvPr/>
+        </p:nvSpPr>
+        <p:spPr>
+          <a:xfrm>
+            <a:off x="914400" y="2194560"/>
+            <a:ext cx="10424160" cy="2377440"/>
+          </a:xfrm>
+          <a:prstGeom prst="rect">
+            <a:avLst/>
+          </a:prstGeom>
+          <a:noFill/>
+          <a:ln/>
+        </p:spPr>
+        <p:txBody>
+          <a:bodyPr wrap="square" rtlCol="0" anchor="ctr"/>
+          <a:lstStyle/>
+          <a:p>
+            <a:pPr marL="177800" indent="-177800">
+              <a:buSzPct val="100000"/>
+              <a:buChar char="•"/>
+            </a:pPr>
+            <a:r>
+              <a:rPr lang="en-US" sz="1500" dirty="0">
                 <a:solidFill>
                   <a:srgbClr val="1C2833"/>
                 </a:solidFill>
               </a:rPr>
-              <a:t>Vision: </a:t>
-            </a:r>
-            <a:endParaRPr lang="en-US" sz="1800" dirty="0"/>
-          </a:p>
-          <a:p>
-            <a:pPr indent="0" marL="0">
-              <a:buNone/>
-            </a:pPr>
-            <a:r>
-              <a:rPr lang="en-US" sz="1800" dirty="0">
-                <a:solidFill>
-                  <a:srgbClr val="334155"/>
-                </a:solidFill>
-              </a:rPr>
-              <a:t>Build a smart, collaborative, and future-ready workplace.</a:t>
-            </a:r>
-            <a:endParaRPr lang="en-US" sz="1800" dirty="0"/>
-          </a:p>
-        </p:txBody>
-      </p:sp>
-      <p:sp>
-        <p:nvSpPr>
-          <p:cNvPr id="6" name="Shape 4"/>
-          <p:cNvSpPr/>
-          <p:nvPr/>
-        </p:nvSpPr>
-        <p:spPr>
-          <a:xfrm>
-            <a:off x="822960" y="3474720"/>
-            <a:ext cx="5029200" cy="868680"/>
+              <a:t>Language includes meaning, context, intent, and emotion.</a:t>
+            </a:r>
+            <a:endParaRPr lang="en-US" sz="1500" dirty="0"/>
+          </a:p>
+          <a:p>
+            <a:pPr marL="177800" indent="-177800">
+              <a:buSzPct val="100000"/>
+              <a:buChar char="•"/>
+            </a:pPr>
+            <a:r>
+              <a:rPr lang="en-US" sz="1500" dirty="0">
+                <a:solidFill>
+                  <a:srgbClr val="1C2833"/>
+                </a:solidFill>
+              </a:rPr>
+              <a:t>Ambiguity is the biggest challenge.</a:t>
+            </a:r>
+            <a:endParaRPr lang="en-US" sz="1500" dirty="0"/>
+          </a:p>
+          <a:p>
+            <a:pPr marL="177800" indent="-177800">
+              <a:buSzPct val="100000"/>
+              <a:buChar char="•"/>
+            </a:pPr>
+            <a:r>
+              <a:rPr lang="en-US" sz="1500" dirty="0">
+                <a:solidFill>
+                  <a:srgbClr val="1C2833"/>
+                </a:solidFill>
+              </a:rPr>
+              <a:t>Humans resolve ambiguity quickly using context; machines need explicit modeling.</a:t>
+            </a:r>
+            <a:endParaRPr lang="en-US" sz="1500" dirty="0"/>
+          </a:p>
+          <a:p>
+            <a:pPr marL="177800" indent="-177800">
+              <a:buSzPct val="100000"/>
+              <a:buChar char="•"/>
+            </a:pPr>
+            <a:r>
+              <a:rPr lang="en-US" sz="1500" dirty="0">
+                <a:solidFill>
+                  <a:srgbClr val="1C2833"/>
+                </a:solidFill>
+              </a:rPr>
+              <a:t>Common issues: sarcasm, idioms, misspellings, slang, negation, and coreference.</a:t>
+            </a:r>
+            <a:endParaRPr lang="en-US" sz="1500" dirty="0"/>
+          </a:p>
+        </p:txBody>
+      </p:sp>
+      <p:sp>
+        <p:nvSpPr>
+          <p:cNvPr id="7" name="Shape 5"/>
+          <p:cNvSpPr/>
+          <p:nvPr/>
+        </p:nvSpPr>
+        <p:spPr>
+          <a:xfrm>
+            <a:off x="822960" y="4937760"/>
+            <a:ext cx="10789920" cy="1188720"/>
           </a:xfrm>
           <a:prstGeom prst="roundRect">
             <a:avLst/>
           </a:prstGeom>
           <a:solidFill>
-            <a:srgbClr val="F3EEFF"/>
+            <a:srgbClr val="FFFFFF"/>
           </a:solidFill>
           <a:ln w="12700">
             <a:solidFill>
-              <a:srgbClr val="D8CCF4"/>
+              <a:srgbClr val="BDC3C7"/>
             </a:solidFill>
             <a:prstDash val="solid"/>
           </a:ln>
@@ -1598,64 +1905,39 @@
       </p:sp>
       <p:sp>
         <p:nvSpPr>
-          <p:cNvPr id="7" name="Text 5"/>
-          <p:cNvSpPr/>
-          <p:nvPr/>
-        </p:nvSpPr>
-        <p:spPr>
-          <a:xfrm>
-            <a:off x="1143000" y="3730752"/>
-            <a:ext cx="4389120" cy="365760"/>
-          </a:xfrm>
-          <a:prstGeom prst="rect">
-            <a:avLst/>
-          </a:prstGeom>
-          <a:noFill/>
-          <a:ln/>
-        </p:spPr>
-        <p:txBody>
-          <a:bodyPr wrap="square" rtlCol="0" anchor="ctr"/>
-          <a:lstStyle/>
-          <a:p>
-            <a:pPr algn="l" indent="0" marL="0">
-              <a:buNone/>
-            </a:pPr>
-            <a:r>
-              <a:rPr lang="en-US" sz="1600" b="1" dirty="0">
+          <p:cNvPr id="8" name="Text 6"/>
+          <p:cNvSpPr/>
+          <p:nvPr/>
+        </p:nvSpPr>
+        <p:spPr>
+          <a:xfrm>
+            <a:off x="1097280" y="5257800"/>
+            <a:ext cx="10241280" cy="640080"/>
+          </a:xfrm>
+          <a:prstGeom prst="rect">
+            <a:avLst/>
+          </a:prstGeom>
+          <a:noFill/>
+          <a:ln/>
+        </p:spPr>
+        <p:txBody>
+          <a:bodyPr wrap="square" rtlCol="0" anchor="ctr"/>
+          <a:lstStyle/>
+          <a:p>
+            <a:pPr indent="0" marL="0">
+              <a:buNone/>
+            </a:pPr>
+            <a:r>
+              <a:rPr lang="en-US" sz="1400" i="1" dirty="0">
                 <a:solidFill>
                   <a:srgbClr val="5234B7"/>
                 </a:solidFill>
               </a:rPr>
-              <a:t>Professionalism</a:t>
-            </a:r>
-            <a:endParaRPr lang="en-US" sz="1600" dirty="0"/>
-          </a:p>
-        </p:txBody>
-      </p:sp>
-      <p:sp>
-        <p:nvSpPr>
-          <p:cNvPr id="8" name="Shape 6"/>
-          <p:cNvSpPr/>
-          <p:nvPr/>
-        </p:nvSpPr>
-        <p:spPr>
-          <a:xfrm>
-            <a:off x="6537960" y="3474720"/>
-            <a:ext cx="5029200" cy="868680"/>
-          </a:xfrm>
-          <a:prstGeom prst="roundRect">
-            <a:avLst/>
-          </a:prstGeom>
-          <a:solidFill>
-            <a:srgbClr val="F9F5FF"/>
-          </a:solidFill>
-          <a:ln w="12700">
-            <a:solidFill>
-              <a:srgbClr val="D8CCF4"/>
-            </a:solidFill>
-            <a:prstDash val="solid"/>
-          </a:ln>
-        </p:spPr>
+              <a:t>Example ambiguity: "I saw the man with the telescope" can mean either you used a telescope, or the man had one.</a:t>
+            </a:r>
+            <a:endParaRPr lang="en-US" sz="1400" dirty="0"/>
+          </a:p>
+        </p:txBody>
       </p:sp>
       <p:sp>
         <p:nvSpPr>
@@ -1665,165 +1947,7 @@
         </p:nvSpPr>
         <p:spPr>
           <a:xfrm>
-            <a:off x="6858000" y="3730752"/>
-            <a:ext cx="4389120" cy="365760"/>
-          </a:xfrm>
-          <a:prstGeom prst="rect">
-            <a:avLst/>
-          </a:prstGeom>
-          <a:noFill/>
-          <a:ln/>
-        </p:spPr>
-        <p:txBody>
-          <a:bodyPr wrap="square" rtlCol="0" anchor="ctr"/>
-          <a:lstStyle/>
-          <a:p>
-            <a:pPr algn="l" indent="0" marL="0">
-              <a:buNone/>
-            </a:pPr>
-            <a:r>
-              <a:rPr lang="en-US" sz="1600" b="1" dirty="0">
-                <a:solidFill>
-                  <a:srgbClr val="5234B7"/>
-                </a:solidFill>
-              </a:rPr>
-              <a:t>Teamwork</a:t>
-            </a:r>
-            <a:endParaRPr lang="en-US" sz="1600" dirty="0"/>
-          </a:p>
-        </p:txBody>
-      </p:sp>
-      <p:sp>
-        <p:nvSpPr>
-          <p:cNvPr id="10" name="Shape 8"/>
-          <p:cNvSpPr/>
-          <p:nvPr/>
-        </p:nvSpPr>
-        <p:spPr>
-          <a:xfrm>
-            <a:off x="822960" y="4709160"/>
-            <a:ext cx="5029200" cy="868680"/>
-          </a:xfrm>
-          <a:prstGeom prst="roundRect">
-            <a:avLst/>
-          </a:prstGeom>
-          <a:solidFill>
-            <a:srgbClr val="F3EEFF"/>
-          </a:solidFill>
-          <a:ln w="12700">
-            <a:solidFill>
-              <a:srgbClr val="D8CCF4"/>
-            </a:solidFill>
-            <a:prstDash val="solid"/>
-          </a:ln>
-        </p:spPr>
-      </p:sp>
-      <p:sp>
-        <p:nvSpPr>
-          <p:cNvPr id="11" name="Text 9"/>
-          <p:cNvSpPr/>
-          <p:nvPr/>
-        </p:nvSpPr>
-        <p:spPr>
-          <a:xfrm>
-            <a:off x="1143000" y="4965192"/>
-            <a:ext cx="4389120" cy="365760"/>
-          </a:xfrm>
-          <a:prstGeom prst="rect">
-            <a:avLst/>
-          </a:prstGeom>
-          <a:noFill/>
-          <a:ln/>
-        </p:spPr>
-        <p:txBody>
-          <a:bodyPr wrap="square" rtlCol="0" anchor="ctr"/>
-          <a:lstStyle/>
-          <a:p>
-            <a:pPr algn="l" indent="0" marL="0">
-              <a:buNone/>
-            </a:pPr>
-            <a:r>
-              <a:rPr lang="en-US" sz="1600" b="1" dirty="0">
-                <a:solidFill>
-                  <a:srgbClr val="5234B7"/>
-                </a:solidFill>
-              </a:rPr>
-              <a:t>Innovation</a:t>
-            </a:r>
-            <a:endParaRPr lang="en-US" sz="1600" dirty="0"/>
-          </a:p>
-        </p:txBody>
-      </p:sp>
-      <p:sp>
-        <p:nvSpPr>
-          <p:cNvPr id="12" name="Shape 10"/>
-          <p:cNvSpPr/>
-          <p:nvPr/>
-        </p:nvSpPr>
-        <p:spPr>
-          <a:xfrm>
-            <a:off x="6537960" y="4709160"/>
-            <a:ext cx="5029200" cy="868680"/>
-          </a:xfrm>
-          <a:prstGeom prst="roundRect">
-            <a:avLst/>
-          </a:prstGeom>
-          <a:solidFill>
-            <a:srgbClr val="F9F5FF"/>
-          </a:solidFill>
-          <a:ln w="12700">
-            <a:solidFill>
-              <a:srgbClr val="D8CCF4"/>
-            </a:solidFill>
-            <a:prstDash val="solid"/>
-          </a:ln>
-        </p:spPr>
-      </p:sp>
-      <p:sp>
-        <p:nvSpPr>
-          <p:cNvPr id="13" name="Text 11"/>
-          <p:cNvSpPr/>
-          <p:nvPr/>
-        </p:nvSpPr>
-        <p:spPr>
-          <a:xfrm>
-            <a:off x="6858000" y="4965192"/>
-            <a:ext cx="4389120" cy="365760"/>
-          </a:xfrm>
-          <a:prstGeom prst="rect">
-            <a:avLst/>
-          </a:prstGeom>
-          <a:noFill/>
-          <a:ln/>
-        </p:spPr>
-        <p:txBody>
-          <a:bodyPr wrap="square" rtlCol="0" anchor="ctr"/>
-          <a:lstStyle/>
-          <a:p>
-            <a:pPr algn="l" indent="0" marL="0">
-              <a:buNone/>
-            </a:pPr>
-            <a:r>
-              <a:rPr lang="en-US" sz="1600" b="1" dirty="0">
-                <a:solidFill>
-                  <a:srgbClr val="5234B7"/>
-                </a:solidFill>
-              </a:rPr>
-              <a:t>Customer Focus</a:t>
-            </a:r>
-            <a:endParaRPr lang="en-US" sz="1600" dirty="0"/>
-          </a:p>
-        </p:txBody>
-      </p:sp>
-      <p:sp>
-        <p:nvSpPr>
-          <p:cNvPr id="14" name="Text 12"/>
-          <p:cNvSpPr/>
-          <p:nvPr/>
-        </p:nvSpPr>
-        <p:spPr>
-          <a:xfrm>
-            <a:off x="548640" y="6583680"/>
+            <a:off x="548640" y="6537960"/>
             <a:ext cx="10972800" cy="274320"/>
           </a:xfrm>
           <a:prstGeom prst="rect">
@@ -1845,7 +1969,7 @@
                   <a:srgbClr val="9CA3AF"/>
                 </a:solidFill>
               </a:rPr>
-              <a:t>Office Presentation | 2</a:t>
+              <a:t>NLP Day 1 | 2</a:t>
             </a:r>
             <a:endParaRPr lang="en-US" sz="1000" dirty="0"/>
           </a:p>
@@ -1917,7 +2041,7 @@
         <p:spPr>
           <a:xfrm>
             <a:off x="548640" y="201168"/>
-            <a:ext cx="7772400" cy="365760"/>
+            <a:ext cx="9601200" cy="365760"/>
           </a:xfrm>
           <a:prstGeom prst="rect">
             <a:avLst/>
@@ -1938,7 +2062,7 @@
                   <a:srgbClr val="FFFFFF"/>
                 </a:solidFill>
               </a:rPr>
-              <a:t>Main Departments</a:t>
+              <a:t>Real-World NLP Applications</a:t>
             </a:r>
             <a:endParaRPr lang="en-US" sz="2000" dirty="0"/>
           </a:p>
@@ -1953,7 +2077,7 @@
         <p:spPr>
           <a:xfrm>
             <a:off x="548640" y="914400"/>
-            <a:ext cx="11155680" cy="365760"/>
+            <a:ext cx="10972800" cy="365760"/>
           </a:xfrm>
           <a:prstGeom prst="rect">
             <a:avLst/>
@@ -1974,7 +2098,7 @@
                   <a:srgbClr val="7F8C8D"/>
                 </a:solidFill>
               </a:rPr>
-              <a:t>How our office is structured</a:t>
+              <a:t>Where NLP appears in daily products</a:t>
             </a:r>
             <a:endParaRPr lang="en-US" sz="1300" dirty="0"/>
           </a:p>
@@ -1982,28 +2106,115 @@
       </p:sp>
       <p:sp>
         <p:nvSpPr>
-          <p:cNvPr id="5" name="Shape 3"/>
-          <p:cNvSpPr/>
-          <p:nvPr/>
-        </p:nvSpPr>
-        <p:spPr>
-          <a:xfrm>
-            <a:off x="822960" y="1554480"/>
-            <a:ext cx="10607040" cy="914400"/>
-          </a:xfrm>
-          <a:prstGeom prst="roundRect">
-            <a:avLst/>
-          </a:prstGeom>
-          <a:solidFill>
-            <a:srgbClr val="FFFFFF"/>
-          </a:solidFill>
-          <a:ln w="12700">
-            <a:solidFill>
-              <a:srgbClr val="BDC3C7"/>
-            </a:solidFill>
-            <a:prstDash val="solid"/>
-          </a:ln>
-        </p:spPr>
+          <p:cNvPr id="5" name="Text 3"/>
+          <p:cNvSpPr/>
+          <p:nvPr/>
+        </p:nvSpPr>
+        <p:spPr>
+          <a:xfrm>
+            <a:off x="822960" y="1463040"/>
+            <a:ext cx="10972800" cy="4389120"/>
+          </a:xfrm>
+          <a:prstGeom prst="rect">
+            <a:avLst/>
+          </a:prstGeom>
+          <a:noFill/>
+          <a:ln/>
+        </p:spPr>
+        <p:txBody>
+          <a:bodyPr wrap="square" rtlCol="0" anchor="ctr"/>
+          <a:lstStyle/>
+          <a:p>
+            <a:pPr marL="177800" indent="-177800">
+              <a:buSzPct val="100000"/>
+              <a:buChar char="•"/>
+            </a:pPr>
+            <a:r>
+              <a:rPr lang="en-US" sz="1600" dirty="0">
+                <a:solidFill>
+                  <a:srgbClr val="1C2833"/>
+                </a:solidFill>
+              </a:rPr>
+              <a:t>Search engines: understanding user intent behind queries.</a:t>
+            </a:r>
+            <a:endParaRPr lang="en-US" sz="1600" dirty="0"/>
+          </a:p>
+          <a:p>
+            <a:pPr marL="177800" indent="-177800">
+              <a:buSzPct val="100000"/>
+              <a:buChar char="•"/>
+            </a:pPr>
+            <a:r>
+              <a:rPr lang="en-US" sz="1600" dirty="0">
+                <a:solidFill>
+                  <a:srgbClr val="1C2833"/>
+                </a:solidFill>
+              </a:rPr>
+              <a:t>Virtual assistants: speech recognition and command interpretation.</a:t>
+            </a:r>
+            <a:endParaRPr lang="en-US" sz="1600" dirty="0"/>
+          </a:p>
+          <a:p>
+            <a:pPr marL="177800" indent="-177800">
+              <a:buSzPct val="100000"/>
+              <a:buChar char="•"/>
+            </a:pPr>
+            <a:r>
+              <a:rPr lang="en-US" sz="1600" dirty="0">
+                <a:solidFill>
+                  <a:srgbClr val="1C2833"/>
+                </a:solidFill>
+              </a:rPr>
+              <a:t>Machine translation: converting meaning across languages.</a:t>
+            </a:r>
+            <a:endParaRPr lang="en-US" sz="1600" dirty="0"/>
+          </a:p>
+          <a:p>
+            <a:pPr marL="177800" indent="-177800">
+              <a:buSzPct val="100000"/>
+              <a:buChar char="•"/>
+            </a:pPr>
+            <a:r>
+              <a:rPr lang="en-US" sz="1600" dirty="0">
+                <a:solidFill>
+                  <a:srgbClr val="1C2833"/>
+                </a:solidFill>
+              </a:rPr>
+              <a:t>Email systems: spam filtering and smart reply generation.</a:t>
+            </a:r>
+            <a:endParaRPr lang="en-US" sz="1600" dirty="0"/>
+          </a:p>
+          <a:p>
+            <a:pPr marL="177800" indent="-177800">
+              <a:buSzPct val="100000"/>
+              <a:buChar char="•"/>
+            </a:pPr>
+            <a:r>
+              <a:rPr lang="en-US" sz="1600" dirty="0">
+                <a:solidFill>
+                  <a:srgbClr val="1C2833"/>
+                </a:solidFill>
+              </a:rPr>
+              <a:t>Healthcare and finance: extracting structured insights from documents.</a:t>
+            </a:r>
+            <a:endParaRPr lang="en-US" sz="1600" dirty="0"/>
+          </a:p>
+          <a:p>
+            <a:pPr marL="177800" indent="-177800">
+              <a:buSzPct val="100000"/>
+              <a:buChar char="•"/>
+            </a:pPr>
+            <a:r>
+              <a:rPr lang="en-US" sz="1600" dirty="0">
+                <a:solidFill>
+                  <a:srgbClr val="1C2833"/>
+                </a:solidFill>
+              </a:rPr>
+              <a:t>Social media moderation: detecting hate speech, abuse, and misinformation.</a:t>
+            </a:r>
+            <a:endParaRPr lang="en-US" sz="1600" dirty="0"/>
+          </a:p>
+        </p:txBody>
       </p:sp>
       <p:sp>
         <p:nvSpPr>
@@ -2013,370 +2224,7 @@
         </p:nvSpPr>
         <p:spPr>
           <a:xfrm>
-            <a:off x="1097280" y="1700784"/>
-            <a:ext cx="2743200" cy="320040"/>
-          </a:xfrm>
-          <a:prstGeom prst="rect">
-            <a:avLst/>
-          </a:prstGeom>
-          <a:noFill/>
-          <a:ln/>
-        </p:spPr>
-        <p:txBody>
-          <a:bodyPr wrap="square" rtlCol="0" anchor="ctr"/>
-          <a:lstStyle/>
-          <a:p>
-            <a:pPr indent="0" marL="0">
-              <a:buNone/>
-            </a:pPr>
-            <a:r>
-              <a:rPr lang="en-US" sz="1500" b="1" dirty="0">
-                <a:solidFill>
-                  <a:srgbClr val="2C3E50"/>
-                </a:solidFill>
-              </a:rPr>
-              <a:t>Operations</a:t>
-            </a:r>
-            <a:endParaRPr lang="en-US" sz="1500" dirty="0"/>
-          </a:p>
-        </p:txBody>
-      </p:sp>
-      <p:sp>
-        <p:nvSpPr>
-          <p:cNvPr id="7" name="Text 5"/>
-          <p:cNvSpPr/>
-          <p:nvPr/>
-        </p:nvSpPr>
-        <p:spPr>
-          <a:xfrm>
-            <a:off x="3657600" y="1737360"/>
-            <a:ext cx="7223760" cy="320040"/>
-          </a:xfrm>
-          <a:prstGeom prst="rect">
-            <a:avLst/>
-          </a:prstGeom>
-          <a:noFill/>
-          <a:ln/>
-        </p:spPr>
-        <p:txBody>
-          <a:bodyPr wrap="square" rtlCol="0" anchor="ctr"/>
-          <a:lstStyle/>
-          <a:p>
-            <a:pPr indent="0" marL="0">
-              <a:buNone/>
-            </a:pPr>
-            <a:r>
-              <a:rPr lang="en-US" sz="1400" dirty="0">
-                <a:solidFill>
-                  <a:srgbClr val="1C2833"/>
-                </a:solidFill>
-              </a:rPr>
-              <a:t>Ensures smooth day-to-day workflow.</a:t>
-            </a:r>
-            <a:endParaRPr lang="en-US" sz="1400" dirty="0"/>
-          </a:p>
-        </p:txBody>
-      </p:sp>
-      <p:sp>
-        <p:nvSpPr>
-          <p:cNvPr id="8" name="Shape 6"/>
-          <p:cNvSpPr/>
-          <p:nvPr/>
-        </p:nvSpPr>
-        <p:spPr>
-          <a:xfrm>
-            <a:off x="822960" y="2743200"/>
-            <a:ext cx="10607040" cy="914400"/>
-          </a:xfrm>
-          <a:prstGeom prst="roundRect">
-            <a:avLst/>
-          </a:prstGeom>
-          <a:solidFill>
-            <a:srgbClr val="F3EEFF"/>
-          </a:solidFill>
-          <a:ln w="12700">
-            <a:solidFill>
-              <a:srgbClr val="BDC3C7"/>
-            </a:solidFill>
-            <a:prstDash val="solid"/>
-          </a:ln>
-        </p:spPr>
-      </p:sp>
-      <p:sp>
-        <p:nvSpPr>
-          <p:cNvPr id="9" name="Text 7"/>
-          <p:cNvSpPr/>
-          <p:nvPr/>
-        </p:nvSpPr>
-        <p:spPr>
-          <a:xfrm>
-            <a:off x="1097280" y="2889504"/>
-            <a:ext cx="2743200" cy="320040"/>
-          </a:xfrm>
-          <a:prstGeom prst="rect">
-            <a:avLst/>
-          </a:prstGeom>
-          <a:noFill/>
-          <a:ln/>
-        </p:spPr>
-        <p:txBody>
-          <a:bodyPr wrap="square" rtlCol="0" anchor="ctr"/>
-          <a:lstStyle/>
-          <a:p>
-            <a:pPr indent="0" marL="0">
-              <a:buNone/>
-            </a:pPr>
-            <a:r>
-              <a:rPr lang="en-US" sz="1500" b="1" dirty="0">
-                <a:solidFill>
-                  <a:srgbClr val="2C3E50"/>
-                </a:solidFill>
-              </a:rPr>
-              <a:t>Sales</a:t>
-            </a:r>
-            <a:endParaRPr lang="en-US" sz="1500" dirty="0"/>
-          </a:p>
-        </p:txBody>
-      </p:sp>
-      <p:sp>
-        <p:nvSpPr>
-          <p:cNvPr id="10" name="Text 8"/>
-          <p:cNvSpPr/>
-          <p:nvPr/>
-        </p:nvSpPr>
-        <p:spPr>
-          <a:xfrm>
-            <a:off x="3657600" y="2926080"/>
-            <a:ext cx="7223760" cy="320040"/>
-          </a:xfrm>
-          <a:prstGeom prst="rect">
-            <a:avLst/>
-          </a:prstGeom>
-          <a:noFill/>
-          <a:ln/>
-        </p:spPr>
-        <p:txBody>
-          <a:bodyPr wrap="square" rtlCol="0" anchor="ctr"/>
-          <a:lstStyle/>
-          <a:p>
-            <a:pPr indent="0" marL="0">
-              <a:buNone/>
-            </a:pPr>
-            <a:r>
-              <a:rPr lang="en-US" sz="1400" dirty="0">
-                <a:solidFill>
-                  <a:srgbClr val="1C2833"/>
-                </a:solidFill>
-              </a:rPr>
-              <a:t>Builds client relationships and growth.</a:t>
-            </a:r>
-            <a:endParaRPr lang="en-US" sz="1400" dirty="0"/>
-          </a:p>
-        </p:txBody>
-      </p:sp>
-      <p:sp>
-        <p:nvSpPr>
-          <p:cNvPr id="11" name="Shape 9"/>
-          <p:cNvSpPr/>
-          <p:nvPr/>
-        </p:nvSpPr>
-        <p:spPr>
-          <a:xfrm>
-            <a:off x="822960" y="3931920"/>
-            <a:ext cx="10607040" cy="914400"/>
-          </a:xfrm>
-          <a:prstGeom prst="roundRect">
-            <a:avLst/>
-          </a:prstGeom>
-          <a:solidFill>
-            <a:srgbClr val="FFFFFF"/>
-          </a:solidFill>
-          <a:ln w="12700">
-            <a:solidFill>
-              <a:srgbClr val="BDC3C7"/>
-            </a:solidFill>
-            <a:prstDash val="solid"/>
-          </a:ln>
-        </p:spPr>
-      </p:sp>
-      <p:sp>
-        <p:nvSpPr>
-          <p:cNvPr id="12" name="Text 10"/>
-          <p:cNvSpPr/>
-          <p:nvPr/>
-        </p:nvSpPr>
-        <p:spPr>
-          <a:xfrm>
-            <a:off x="1097280" y="4078224"/>
-            <a:ext cx="2743200" cy="320040"/>
-          </a:xfrm>
-          <a:prstGeom prst="rect">
-            <a:avLst/>
-          </a:prstGeom>
-          <a:noFill/>
-          <a:ln/>
-        </p:spPr>
-        <p:txBody>
-          <a:bodyPr wrap="square" rtlCol="0" anchor="ctr"/>
-          <a:lstStyle/>
-          <a:p>
-            <a:pPr indent="0" marL="0">
-              <a:buNone/>
-            </a:pPr>
-            <a:r>
-              <a:rPr lang="en-US" sz="1500" b="1" dirty="0">
-                <a:solidFill>
-                  <a:srgbClr val="2C3E50"/>
-                </a:solidFill>
-              </a:rPr>
-              <a:t>Human Resources</a:t>
-            </a:r>
-            <a:endParaRPr lang="en-US" sz="1500" dirty="0"/>
-          </a:p>
-        </p:txBody>
-      </p:sp>
-      <p:sp>
-        <p:nvSpPr>
-          <p:cNvPr id="13" name="Text 11"/>
-          <p:cNvSpPr/>
-          <p:nvPr/>
-        </p:nvSpPr>
-        <p:spPr>
-          <a:xfrm>
-            <a:off x="3657600" y="4114800"/>
-            <a:ext cx="7223760" cy="320040"/>
-          </a:xfrm>
-          <a:prstGeom prst="rect">
-            <a:avLst/>
-          </a:prstGeom>
-          <a:noFill/>
-          <a:ln/>
-        </p:spPr>
-        <p:txBody>
-          <a:bodyPr wrap="square" rtlCol="0" anchor="ctr"/>
-          <a:lstStyle/>
-          <a:p>
-            <a:pPr indent="0" marL="0">
-              <a:buNone/>
-            </a:pPr>
-            <a:r>
-              <a:rPr lang="en-US" sz="1400" dirty="0">
-                <a:solidFill>
-                  <a:srgbClr val="1C2833"/>
-                </a:solidFill>
-              </a:rPr>
-              <a:t>Supports people and culture.</a:t>
-            </a:r>
-            <a:endParaRPr lang="en-US" sz="1400" dirty="0"/>
-          </a:p>
-        </p:txBody>
-      </p:sp>
-      <p:sp>
-        <p:nvSpPr>
-          <p:cNvPr id="14" name="Shape 12"/>
-          <p:cNvSpPr/>
-          <p:nvPr/>
-        </p:nvSpPr>
-        <p:spPr>
-          <a:xfrm>
-            <a:off x="822960" y="5120640"/>
-            <a:ext cx="10607040" cy="914400"/>
-          </a:xfrm>
-          <a:prstGeom prst="roundRect">
-            <a:avLst/>
-          </a:prstGeom>
-          <a:solidFill>
-            <a:srgbClr val="F3EEFF"/>
-          </a:solidFill>
-          <a:ln w="12700">
-            <a:solidFill>
-              <a:srgbClr val="BDC3C7"/>
-            </a:solidFill>
-            <a:prstDash val="solid"/>
-          </a:ln>
-        </p:spPr>
-      </p:sp>
-      <p:sp>
-        <p:nvSpPr>
-          <p:cNvPr id="15" name="Text 13"/>
-          <p:cNvSpPr/>
-          <p:nvPr/>
-        </p:nvSpPr>
-        <p:spPr>
-          <a:xfrm>
-            <a:off x="1097280" y="5266944"/>
-            <a:ext cx="2743200" cy="320040"/>
-          </a:xfrm>
-          <a:prstGeom prst="rect">
-            <a:avLst/>
-          </a:prstGeom>
-          <a:noFill/>
-          <a:ln/>
-        </p:spPr>
-        <p:txBody>
-          <a:bodyPr wrap="square" rtlCol="0" anchor="ctr"/>
-          <a:lstStyle/>
-          <a:p>
-            <a:pPr indent="0" marL="0">
-              <a:buNone/>
-            </a:pPr>
-            <a:r>
-              <a:rPr lang="en-US" sz="1500" b="1" dirty="0">
-                <a:solidFill>
-                  <a:srgbClr val="2C3E50"/>
-                </a:solidFill>
-              </a:rPr>
-              <a:t>Finance</a:t>
-            </a:r>
-            <a:endParaRPr lang="en-US" sz="1500" dirty="0"/>
-          </a:p>
-        </p:txBody>
-      </p:sp>
-      <p:sp>
-        <p:nvSpPr>
-          <p:cNvPr id="16" name="Text 14"/>
-          <p:cNvSpPr/>
-          <p:nvPr/>
-        </p:nvSpPr>
-        <p:spPr>
-          <a:xfrm>
-            <a:off x="3657600" y="5303520"/>
-            <a:ext cx="7223760" cy="320040"/>
-          </a:xfrm>
-          <a:prstGeom prst="rect">
-            <a:avLst/>
-          </a:prstGeom>
-          <a:noFill/>
-          <a:ln/>
-        </p:spPr>
-        <p:txBody>
-          <a:bodyPr wrap="square" rtlCol="0" anchor="ctr"/>
-          <a:lstStyle/>
-          <a:p>
-            <a:pPr indent="0" marL="0">
-              <a:buNone/>
-            </a:pPr>
-            <a:r>
-              <a:rPr lang="en-US" sz="1400" dirty="0">
-                <a:solidFill>
-                  <a:srgbClr val="1C2833"/>
-                </a:solidFill>
-              </a:rPr>
-              <a:t>Manages budgets and financial planning.</a:t>
-            </a:r>
-            <a:endParaRPr lang="en-US" sz="1400" dirty="0"/>
-          </a:p>
-        </p:txBody>
-      </p:sp>
-      <p:sp>
-        <p:nvSpPr>
-          <p:cNvPr id="17" name="Text 15"/>
-          <p:cNvSpPr/>
-          <p:nvPr/>
-        </p:nvSpPr>
-        <p:spPr>
-          <a:xfrm>
-            <a:off x="548640" y="6583680"/>
+            <a:off x="548640" y="6537960"/>
             <a:ext cx="10972800" cy="274320"/>
           </a:xfrm>
           <a:prstGeom prst="rect">
@@ -2398,7 +2246,7 @@
                   <a:srgbClr val="9CA3AF"/>
                 </a:solidFill>
               </a:rPr>
-              <a:t>Office Presentation | 3</a:t>
+              <a:t>NLP Day 1 | 3</a:t>
             </a:r>
             <a:endParaRPr lang="en-US" sz="1000" dirty="0"/>
           </a:p>
@@ -2470,7 +2318,7 @@
         <p:spPr>
           <a:xfrm>
             <a:off x="548640" y="201168"/>
-            <a:ext cx="7772400" cy="365760"/>
+            <a:ext cx="9601200" cy="365760"/>
           </a:xfrm>
           <a:prstGeom prst="rect">
             <a:avLst/>
@@ -2491,7 +2339,7 @@
                   <a:srgbClr val="FFFFFF"/>
                 </a:solidFill>
               </a:rPr>
-              <a:t>Daily Workflow</a:t>
+              <a:t>The Full NLP Pipeline</a:t>
             </a:r>
             <a:endParaRPr lang="en-US" sz="2000" dirty="0"/>
           </a:p>
@@ -2506,7 +2354,7 @@
         <p:spPr>
           <a:xfrm>
             <a:off x="548640" y="914400"/>
-            <a:ext cx="11155680" cy="365760"/>
+            <a:ext cx="10972800" cy="365760"/>
           </a:xfrm>
           <a:prstGeom prst="rect">
             <a:avLst/>
@@ -2527,7 +2375,7 @@
                   <a:srgbClr val="7F8C8D"/>
                 </a:solidFill>
               </a:rPr>
-              <a:t>A typical productive day</a:t>
+              <a:t>From raw text to structured data</a:t>
             </a:r>
             <a:endParaRPr lang="en-US" sz="1300" dirty="0"/>
           </a:p>
@@ -2541,18 +2389,18 @@
         </p:nvSpPr>
         <p:spPr>
           <a:xfrm>
-            <a:off x="914400" y="1828800"/>
-            <a:ext cx="777240" cy="777240"/>
-          </a:xfrm>
-          <a:prstGeom prst="ellipse">
+            <a:off x="914400" y="1554480"/>
+            <a:ext cx="4572000" cy="502920"/>
+          </a:xfrm>
+          <a:prstGeom prst="roundRect">
             <a:avLst/>
           </a:prstGeom>
           <a:solidFill>
-            <a:srgbClr val="5234B7"/>
+            <a:srgbClr val="FFFFFF"/>
           </a:solidFill>
           <a:ln w="12700">
             <a:solidFill>
-              <a:srgbClr val="5234B7"/>
+              <a:srgbClr val="BDC3C7"/>
             </a:solidFill>
             <a:prstDash val="solid"/>
           </a:ln>
@@ -2566,44 +2414,8 @@
         </p:nvSpPr>
         <p:spPr>
           <a:xfrm>
-            <a:off x="914400" y="2048256"/>
-            <a:ext cx="777240" cy="228600"/>
-          </a:xfrm>
-          <a:prstGeom prst="rect">
-            <a:avLst/>
-          </a:prstGeom>
-          <a:noFill/>
-          <a:ln/>
-        </p:spPr>
-        <p:txBody>
-          <a:bodyPr wrap="square" rtlCol="0" anchor="ctr"/>
-          <a:lstStyle/>
-          <a:p>
-            <a:pPr algn="ctr" indent="0" marL="0">
-              <a:buNone/>
-            </a:pPr>
-            <a:r>
-              <a:rPr lang="en-US" sz="1400" b="1" dirty="0">
-                <a:solidFill>
-                  <a:srgbClr val="FFFFFF"/>
-                </a:solidFill>
-              </a:rPr>
-              <a:t>1</a:t>
-            </a:r>
-            <a:endParaRPr lang="en-US" sz="1400" dirty="0"/>
-          </a:p>
-        </p:txBody>
-      </p:sp>
-      <p:sp>
-        <p:nvSpPr>
-          <p:cNvPr id="7" name="Text 5"/>
-          <p:cNvSpPr/>
-          <p:nvPr/>
-        </p:nvSpPr>
-        <p:spPr>
-          <a:xfrm>
-            <a:off x="1920240" y="1901952"/>
-            <a:ext cx="1188720" cy="274320"/>
+            <a:off x="1097280" y="1691640"/>
+            <a:ext cx="4206240" cy="228600"/>
           </a:xfrm>
           <a:prstGeom prst="rect">
             <a:avLst/>
@@ -2624,7 +2436,7 @@
                   <a:srgbClr val="2C3E50"/>
                 </a:solidFill>
               </a:rPr>
-              <a:t>09:00</a:t>
+              <a:t>1) Text Cleaning</a:t>
             </a:r>
             <a:endParaRPr lang="en-US" sz="1300" dirty="0"/>
           </a:p>
@@ -2632,60 +2444,24 @@
       </p:sp>
       <p:sp>
         <p:nvSpPr>
-          <p:cNvPr id="8" name="Text 6"/>
-          <p:cNvSpPr/>
-          <p:nvPr/>
-        </p:nvSpPr>
-        <p:spPr>
-          <a:xfrm>
-            <a:off x="3017520" y="1901952"/>
-            <a:ext cx="8046720" cy="274320"/>
-          </a:xfrm>
-          <a:prstGeom prst="rect">
-            <a:avLst/>
-          </a:prstGeom>
-          <a:noFill/>
-          <a:ln/>
-        </p:spPr>
-        <p:txBody>
-          <a:bodyPr wrap="square" rtlCol="0" anchor="ctr"/>
-          <a:lstStyle/>
-          <a:p>
-            <a:pPr indent="0" marL="0">
-              <a:buNone/>
-            </a:pPr>
-            <a:r>
-              <a:rPr lang="en-US" sz="1400" dirty="0">
-                <a:solidFill>
-                  <a:srgbClr val="1C2833"/>
-                </a:solidFill>
-              </a:rPr>
-              <a:t>Team Stand-up &amp; Priority Setting</a:t>
-            </a:r>
-            <a:endParaRPr lang="en-US" sz="1400" dirty="0"/>
-          </a:p>
-        </p:txBody>
-      </p:sp>
-      <p:sp>
-        <p:nvSpPr>
-          <p:cNvPr id="9" name="Shape 7"/>
-          <p:cNvSpPr/>
-          <p:nvPr/>
-        </p:nvSpPr>
-        <p:spPr>
-          <a:xfrm>
-            <a:off x="914400" y="2971800"/>
-            <a:ext cx="777240" cy="777240"/>
-          </a:xfrm>
-          <a:prstGeom prst="ellipse">
+          <p:cNvPr id="7" name="Shape 5"/>
+          <p:cNvSpPr/>
+          <p:nvPr/>
+        </p:nvSpPr>
+        <p:spPr>
+          <a:xfrm>
+            <a:off x="914400" y="2231136"/>
+            <a:ext cx="4572000" cy="502920"/>
+          </a:xfrm>
+          <a:prstGeom prst="roundRect">
             <a:avLst/>
           </a:prstGeom>
           <a:solidFill>
-            <a:srgbClr val="5234B7"/>
+            <a:srgbClr val="F8FAFC"/>
           </a:solidFill>
           <a:ln w="12700">
             <a:solidFill>
-              <a:srgbClr val="5234B7"/>
+              <a:srgbClr val="BDC3C7"/>
             </a:solidFill>
             <a:prstDash val="solid"/>
           </a:ln>
@@ -2693,50 +2469,14 @@
       </p:sp>
       <p:sp>
         <p:nvSpPr>
-          <p:cNvPr id="10" name="Text 8"/>
-          <p:cNvSpPr/>
-          <p:nvPr/>
-        </p:nvSpPr>
-        <p:spPr>
-          <a:xfrm>
-            <a:off x="914400" y="3191256"/>
-            <a:ext cx="777240" cy="228600"/>
-          </a:xfrm>
-          <a:prstGeom prst="rect">
-            <a:avLst/>
-          </a:prstGeom>
-          <a:noFill/>
-          <a:ln/>
-        </p:spPr>
-        <p:txBody>
-          <a:bodyPr wrap="square" rtlCol="0" anchor="ctr"/>
-          <a:lstStyle/>
-          <a:p>
-            <a:pPr algn="ctr" indent="0" marL="0">
-              <a:buNone/>
-            </a:pPr>
-            <a:r>
-              <a:rPr lang="en-US" sz="1400" b="1" dirty="0">
-                <a:solidFill>
-                  <a:srgbClr val="FFFFFF"/>
-                </a:solidFill>
-              </a:rPr>
-              <a:t>2</a:t>
-            </a:r>
-            <a:endParaRPr lang="en-US" sz="1400" dirty="0"/>
-          </a:p>
-        </p:txBody>
-      </p:sp>
-      <p:sp>
-        <p:nvSpPr>
-          <p:cNvPr id="11" name="Text 9"/>
-          <p:cNvSpPr/>
-          <p:nvPr/>
-        </p:nvSpPr>
-        <p:spPr>
-          <a:xfrm>
-            <a:off x="1920240" y="3044952"/>
-            <a:ext cx="1188720" cy="274320"/>
+          <p:cNvPr id="8" name="Text 6"/>
+          <p:cNvSpPr/>
+          <p:nvPr/>
+        </p:nvSpPr>
+        <p:spPr>
+          <a:xfrm>
+            <a:off x="1097280" y="2368296"/>
+            <a:ext cx="4206240" cy="228600"/>
           </a:xfrm>
           <a:prstGeom prst="rect">
             <a:avLst/>
@@ -2757,7 +2497,7 @@
                   <a:srgbClr val="2C3E50"/>
                 </a:solidFill>
               </a:rPr>
-              <a:t>11:00</a:t>
+              <a:t>2) Tokenization</a:t>
             </a:r>
             <a:endParaRPr lang="en-US" sz="1300" dirty="0"/>
           </a:p>
@@ -2765,60 +2505,24 @@
       </p:sp>
       <p:sp>
         <p:nvSpPr>
-          <p:cNvPr id="12" name="Text 10"/>
-          <p:cNvSpPr/>
-          <p:nvPr/>
-        </p:nvSpPr>
-        <p:spPr>
-          <a:xfrm>
-            <a:off x="3017520" y="3044952"/>
-            <a:ext cx="8046720" cy="274320"/>
-          </a:xfrm>
-          <a:prstGeom prst="rect">
-            <a:avLst/>
-          </a:prstGeom>
-          <a:noFill/>
-          <a:ln/>
-        </p:spPr>
-        <p:txBody>
-          <a:bodyPr wrap="square" rtlCol="0" anchor="ctr"/>
-          <a:lstStyle/>
-          <a:p>
-            <a:pPr indent="0" marL="0">
-              <a:buNone/>
-            </a:pPr>
-            <a:r>
-              <a:rPr lang="en-US" sz="1400" dirty="0">
-                <a:solidFill>
-                  <a:srgbClr val="1C2833"/>
-                </a:solidFill>
-              </a:rPr>
-              <a:t>Client Communication &amp; Follow-ups</a:t>
-            </a:r>
-            <a:endParaRPr lang="en-US" sz="1400" dirty="0"/>
-          </a:p>
-        </p:txBody>
-      </p:sp>
-      <p:sp>
-        <p:nvSpPr>
-          <p:cNvPr id="13" name="Shape 11"/>
-          <p:cNvSpPr/>
-          <p:nvPr/>
-        </p:nvSpPr>
-        <p:spPr>
-          <a:xfrm>
-            <a:off x="914400" y="4114800"/>
-            <a:ext cx="777240" cy="777240"/>
-          </a:xfrm>
-          <a:prstGeom prst="ellipse">
+          <p:cNvPr id="9" name="Shape 7"/>
+          <p:cNvSpPr/>
+          <p:nvPr/>
+        </p:nvSpPr>
+        <p:spPr>
+          <a:xfrm>
+            <a:off x="914400" y="2907792"/>
+            <a:ext cx="4572000" cy="502920"/>
+          </a:xfrm>
+          <a:prstGeom prst="roundRect">
             <a:avLst/>
           </a:prstGeom>
           <a:solidFill>
-            <a:srgbClr val="5234B7"/>
+            <a:srgbClr val="FFFFFF"/>
           </a:solidFill>
           <a:ln w="12700">
             <a:solidFill>
-              <a:srgbClr val="5234B7"/>
+              <a:srgbClr val="BDC3C7"/>
             </a:solidFill>
             <a:prstDash val="solid"/>
           </a:ln>
@@ -2826,50 +2530,14 @@
       </p:sp>
       <p:sp>
         <p:nvSpPr>
-          <p:cNvPr id="14" name="Text 12"/>
-          <p:cNvSpPr/>
-          <p:nvPr/>
-        </p:nvSpPr>
-        <p:spPr>
-          <a:xfrm>
-            <a:off x="914400" y="4334256"/>
-            <a:ext cx="777240" cy="228600"/>
-          </a:xfrm>
-          <a:prstGeom prst="rect">
-            <a:avLst/>
-          </a:prstGeom>
-          <a:noFill/>
-          <a:ln/>
-        </p:spPr>
-        <p:txBody>
-          <a:bodyPr wrap="square" rtlCol="0" anchor="ctr"/>
-          <a:lstStyle/>
-          <a:p>
-            <a:pPr algn="ctr" indent="0" marL="0">
-              <a:buNone/>
-            </a:pPr>
-            <a:r>
-              <a:rPr lang="en-US" sz="1400" b="1" dirty="0">
-                <a:solidFill>
-                  <a:srgbClr val="FFFFFF"/>
-                </a:solidFill>
-              </a:rPr>
-              <a:t>3</a:t>
-            </a:r>
-            <a:endParaRPr lang="en-US" sz="1400" dirty="0"/>
-          </a:p>
-        </p:txBody>
-      </p:sp>
-      <p:sp>
-        <p:nvSpPr>
-          <p:cNvPr id="15" name="Text 13"/>
-          <p:cNvSpPr/>
-          <p:nvPr/>
-        </p:nvSpPr>
-        <p:spPr>
-          <a:xfrm>
-            <a:off x="1920240" y="4187952"/>
-            <a:ext cx="1188720" cy="274320"/>
+          <p:cNvPr id="10" name="Text 8"/>
+          <p:cNvSpPr/>
+          <p:nvPr/>
+        </p:nvSpPr>
+        <p:spPr>
+          <a:xfrm>
+            <a:off x="1097280" y="3044952"/>
+            <a:ext cx="4206240" cy="228600"/>
           </a:xfrm>
           <a:prstGeom prst="rect">
             <a:avLst/>
@@ -2890,7 +2558,7 @@
                   <a:srgbClr val="2C3E50"/>
                 </a:solidFill>
               </a:rPr>
-              <a:t>13:00</a:t>
+              <a:t>3) Stop Words Handling</a:t>
             </a:r>
             <a:endParaRPr lang="en-US" sz="1300" dirty="0"/>
           </a:p>
@@ -2898,60 +2566,24 @@
       </p:sp>
       <p:sp>
         <p:nvSpPr>
-          <p:cNvPr id="16" name="Text 14"/>
-          <p:cNvSpPr/>
-          <p:nvPr/>
-        </p:nvSpPr>
-        <p:spPr>
-          <a:xfrm>
-            <a:off x="3017520" y="4187952"/>
-            <a:ext cx="8046720" cy="274320"/>
-          </a:xfrm>
-          <a:prstGeom prst="rect">
-            <a:avLst/>
-          </a:prstGeom>
-          <a:noFill/>
-          <a:ln/>
-        </p:spPr>
-        <p:txBody>
-          <a:bodyPr wrap="square" rtlCol="0" anchor="ctr"/>
-          <a:lstStyle/>
-          <a:p>
-            <a:pPr indent="0" marL="0">
-              <a:buNone/>
-            </a:pPr>
-            <a:r>
-              <a:rPr lang="en-US" sz="1400" dirty="0">
-                <a:solidFill>
-                  <a:srgbClr val="1C2833"/>
-                </a:solidFill>
-              </a:rPr>
-              <a:t>Project Execution &amp; Collaboration</a:t>
-            </a:r>
-            <a:endParaRPr lang="en-US" sz="1400" dirty="0"/>
-          </a:p>
-        </p:txBody>
-      </p:sp>
-      <p:sp>
-        <p:nvSpPr>
-          <p:cNvPr id="17" name="Shape 15"/>
-          <p:cNvSpPr/>
-          <p:nvPr/>
-        </p:nvSpPr>
-        <p:spPr>
-          <a:xfrm>
-            <a:off x="914400" y="5257800"/>
-            <a:ext cx="777240" cy="777240"/>
-          </a:xfrm>
-          <a:prstGeom prst="ellipse">
+          <p:cNvPr id="11" name="Shape 9"/>
+          <p:cNvSpPr/>
+          <p:nvPr/>
+        </p:nvSpPr>
+        <p:spPr>
+          <a:xfrm>
+            <a:off x="914400" y="3584448"/>
+            <a:ext cx="4572000" cy="502920"/>
+          </a:xfrm>
+          <a:prstGeom prst="roundRect">
             <a:avLst/>
           </a:prstGeom>
           <a:solidFill>
-            <a:srgbClr val="5234B7"/>
+            <a:srgbClr val="F8FAFC"/>
           </a:solidFill>
           <a:ln w="12700">
             <a:solidFill>
-              <a:srgbClr val="5234B7"/>
+              <a:srgbClr val="BDC3C7"/>
             </a:solidFill>
             <a:prstDash val="solid"/>
           </a:ln>
@@ -2959,50 +2591,197 @@
       </p:sp>
       <p:sp>
         <p:nvSpPr>
+          <p:cNvPr id="12" name="Text 10"/>
+          <p:cNvSpPr/>
+          <p:nvPr/>
+        </p:nvSpPr>
+        <p:spPr>
+          <a:xfrm>
+            <a:off x="1097280" y="3721608"/>
+            <a:ext cx="4206240" cy="228600"/>
+          </a:xfrm>
+          <a:prstGeom prst="rect">
+            <a:avLst/>
+          </a:prstGeom>
+          <a:noFill/>
+          <a:ln/>
+        </p:spPr>
+        <p:txBody>
+          <a:bodyPr wrap="square" rtlCol="0" anchor="ctr"/>
+          <a:lstStyle/>
+          <a:p>
+            <a:pPr indent="0" marL="0">
+              <a:buNone/>
+            </a:pPr>
+            <a:r>
+              <a:rPr lang="en-US" sz="1300" b="1" dirty="0">
+                <a:solidFill>
+                  <a:srgbClr val="2C3E50"/>
+                </a:solidFill>
+              </a:rPr>
+              <a:t>4) Normalization</a:t>
+            </a:r>
+            <a:endParaRPr lang="en-US" sz="1300" dirty="0"/>
+          </a:p>
+        </p:txBody>
+      </p:sp>
+      <p:sp>
+        <p:nvSpPr>
+          <p:cNvPr id="13" name="Shape 11"/>
+          <p:cNvSpPr/>
+          <p:nvPr/>
+        </p:nvSpPr>
+        <p:spPr>
+          <a:xfrm>
+            <a:off x="914400" y="4261104"/>
+            <a:ext cx="4572000" cy="502920"/>
+          </a:xfrm>
+          <a:prstGeom prst="roundRect">
+            <a:avLst/>
+          </a:prstGeom>
+          <a:solidFill>
+            <a:srgbClr val="FFFFFF"/>
+          </a:solidFill>
+          <a:ln w="12700">
+            <a:solidFill>
+              <a:srgbClr val="BDC3C7"/>
+            </a:solidFill>
+            <a:prstDash val="solid"/>
+          </a:ln>
+        </p:spPr>
+      </p:sp>
+      <p:sp>
+        <p:nvSpPr>
+          <p:cNvPr id="14" name="Text 12"/>
+          <p:cNvSpPr/>
+          <p:nvPr/>
+        </p:nvSpPr>
+        <p:spPr>
+          <a:xfrm>
+            <a:off x="1097280" y="4398264"/>
+            <a:ext cx="4206240" cy="228600"/>
+          </a:xfrm>
+          <a:prstGeom prst="rect">
+            <a:avLst/>
+          </a:prstGeom>
+          <a:noFill/>
+          <a:ln/>
+        </p:spPr>
+        <p:txBody>
+          <a:bodyPr wrap="square" rtlCol="0" anchor="ctr"/>
+          <a:lstStyle/>
+          <a:p>
+            <a:pPr indent="0" marL="0">
+              <a:buNone/>
+            </a:pPr>
+            <a:r>
+              <a:rPr lang="en-US" sz="1300" b="1" dirty="0">
+                <a:solidFill>
+                  <a:srgbClr val="2C3E50"/>
+                </a:solidFill>
+              </a:rPr>
+              <a:t>5) Stemming or Lemmatization</a:t>
+            </a:r>
+            <a:endParaRPr lang="en-US" sz="1300" dirty="0"/>
+          </a:p>
+        </p:txBody>
+      </p:sp>
+      <p:sp>
+        <p:nvSpPr>
+          <p:cNvPr id="15" name="Shape 13"/>
+          <p:cNvSpPr/>
+          <p:nvPr/>
+        </p:nvSpPr>
+        <p:spPr>
+          <a:xfrm>
+            <a:off x="914400" y="4937760"/>
+            <a:ext cx="4572000" cy="502920"/>
+          </a:xfrm>
+          <a:prstGeom prst="roundRect">
+            <a:avLst/>
+          </a:prstGeom>
+          <a:solidFill>
+            <a:srgbClr val="F8FAFC"/>
+          </a:solidFill>
+          <a:ln w="12700">
+            <a:solidFill>
+              <a:srgbClr val="BDC3C7"/>
+            </a:solidFill>
+            <a:prstDash val="solid"/>
+          </a:ln>
+        </p:spPr>
+      </p:sp>
+      <p:sp>
+        <p:nvSpPr>
+          <p:cNvPr id="16" name="Text 14"/>
+          <p:cNvSpPr/>
+          <p:nvPr/>
+        </p:nvSpPr>
+        <p:spPr>
+          <a:xfrm>
+            <a:off x="1097280" y="5074920"/>
+            <a:ext cx="4206240" cy="228600"/>
+          </a:xfrm>
+          <a:prstGeom prst="rect">
+            <a:avLst/>
+          </a:prstGeom>
+          <a:noFill/>
+          <a:ln/>
+        </p:spPr>
+        <p:txBody>
+          <a:bodyPr wrap="square" rtlCol="0" anchor="ctr"/>
+          <a:lstStyle/>
+          <a:p>
+            <a:pPr indent="0" marL="0">
+              <a:buNone/>
+            </a:pPr>
+            <a:r>
+              <a:rPr lang="en-US" sz="1300" b="1" dirty="0">
+                <a:solidFill>
+                  <a:srgbClr val="2C3E50"/>
+                </a:solidFill>
+              </a:rPr>
+              <a:t>6) POS Tagging</a:t>
+            </a:r>
+            <a:endParaRPr lang="en-US" sz="1300" dirty="0"/>
+          </a:p>
+        </p:txBody>
+      </p:sp>
+      <p:sp>
+        <p:nvSpPr>
+          <p:cNvPr id="17" name="Shape 15"/>
+          <p:cNvSpPr/>
+          <p:nvPr/>
+        </p:nvSpPr>
+        <p:spPr>
+          <a:xfrm>
+            <a:off x="914400" y="5614416"/>
+            <a:ext cx="4572000" cy="502920"/>
+          </a:xfrm>
+          <a:prstGeom prst="roundRect">
+            <a:avLst/>
+          </a:prstGeom>
+          <a:solidFill>
+            <a:srgbClr val="FFFFFF"/>
+          </a:solidFill>
+          <a:ln w="12700">
+            <a:solidFill>
+              <a:srgbClr val="BDC3C7"/>
+            </a:solidFill>
+            <a:prstDash val="solid"/>
+          </a:ln>
+        </p:spPr>
+      </p:sp>
+      <p:sp>
+        <p:nvSpPr>
           <p:cNvPr id="18" name="Text 16"/>
           <p:cNvSpPr/>
           <p:nvPr/>
         </p:nvSpPr>
         <p:spPr>
           <a:xfrm>
-            <a:off x="914400" y="5477256"/>
-            <a:ext cx="777240" cy="228600"/>
-          </a:xfrm>
-          <a:prstGeom prst="rect">
-            <a:avLst/>
-          </a:prstGeom>
-          <a:noFill/>
-          <a:ln/>
-        </p:spPr>
-        <p:txBody>
-          <a:bodyPr wrap="square" rtlCol="0" anchor="ctr"/>
-          <a:lstStyle/>
-          <a:p>
-            <a:pPr algn="ctr" indent="0" marL="0">
-              <a:buNone/>
-            </a:pPr>
-            <a:r>
-              <a:rPr lang="en-US" sz="1400" b="1" dirty="0">
-                <a:solidFill>
-                  <a:srgbClr val="FFFFFF"/>
-                </a:solidFill>
-              </a:rPr>
-              <a:t>4</a:t>
-            </a:r>
-            <a:endParaRPr lang="en-US" sz="1400" dirty="0"/>
-          </a:p>
-        </p:txBody>
-      </p:sp>
-      <p:sp>
-        <p:nvSpPr>
-          <p:cNvPr id="19" name="Text 17"/>
-          <p:cNvSpPr/>
-          <p:nvPr/>
-        </p:nvSpPr>
-        <p:spPr>
-          <a:xfrm>
-            <a:off x="1920240" y="5330952"/>
-            <a:ext cx="1188720" cy="274320"/>
+            <a:off x="1097280" y="5751576"/>
+            <a:ext cx="4206240" cy="228600"/>
           </a:xfrm>
           <a:prstGeom prst="rect">
             <a:avLst/>
@@ -3023,7 +2802,7 @@
                   <a:srgbClr val="2C3E50"/>
                 </a:solidFill>
               </a:rPr>
-              <a:t>16:00</a:t>
+              <a:t>7) Named Entity Recognition</a:t>
             </a:r>
             <a:endParaRPr lang="en-US" sz="1300" dirty="0"/>
           </a:p>
@@ -3031,14 +2810,39 @@
       </p:sp>
       <p:sp>
         <p:nvSpPr>
+          <p:cNvPr id="19" name="Shape 17"/>
+          <p:cNvSpPr/>
+          <p:nvPr/>
+        </p:nvSpPr>
+        <p:spPr>
+          <a:xfrm>
+            <a:off x="5852160" y="1645920"/>
+            <a:ext cx="5303520" cy="4206240"/>
+          </a:xfrm>
+          <a:prstGeom prst="roundRect">
+            <a:avLst/>
+          </a:prstGeom>
+          <a:solidFill>
+            <a:srgbClr val="FFFFFF"/>
+          </a:solidFill>
+          <a:ln w="12700">
+            <a:solidFill>
+              <a:srgbClr val="BDC3C7"/>
+            </a:solidFill>
+            <a:prstDash val="solid"/>
+          </a:ln>
+        </p:spPr>
+      </p:sp>
+      <p:sp>
+        <p:nvSpPr>
           <p:cNvPr id="20" name="Text 18"/>
           <p:cNvSpPr/>
           <p:nvPr/>
         </p:nvSpPr>
         <p:spPr>
           <a:xfrm>
-            <a:off x="3017520" y="5330952"/>
-            <a:ext cx="8046720" cy="274320"/>
+            <a:off x="6126480" y="1874520"/>
+            <a:ext cx="4754880" cy="274320"/>
           </a:xfrm>
           <a:prstGeom prst="rect">
             <a:avLst/>
@@ -3054,26 +2858,76 @@
               <a:buNone/>
             </a:pPr>
             <a:r>
-              <a:rPr lang="en-US" sz="1400" dirty="0">
+              <a:rPr lang="en-US" sz="1500" b="1" dirty="0">
+                <a:solidFill>
+                  <a:srgbClr val="5234B7"/>
+                </a:solidFill>
+              </a:rPr>
+              <a:t>Example Flow</a:t>
+            </a:r>
+            <a:endParaRPr lang="en-US" sz="1500" dirty="0"/>
+          </a:p>
+        </p:txBody>
+      </p:sp>
+      <p:sp>
+        <p:nvSpPr>
+          <p:cNvPr id="21" name="Text 19"/>
+          <p:cNvSpPr/>
+          <p:nvPr/>
+        </p:nvSpPr>
+        <p:spPr>
+          <a:xfrm>
+            <a:off x="6126480" y="2240280"/>
+            <a:ext cx="4663440" cy="2103120"/>
+          </a:xfrm>
+          <a:prstGeom prst="rect">
+            <a:avLst/>
+          </a:prstGeom>
+          <a:noFill/>
+          <a:ln/>
+        </p:spPr>
+        <p:txBody>
+          <a:bodyPr wrap="square" rtlCol="0" anchor="t"/>
+          <a:lstStyle/>
+          <a:p>
+            <a:pPr indent="0" marL="0">
+              <a:buNone/>
+            </a:pPr>
+            <a:r>
+              <a:rPr lang="en-US" sz="1300" dirty="0">
                 <a:solidFill>
                   <a:srgbClr val="1C2833"/>
                 </a:solidFill>
               </a:rPr>
-              <a:t>Reporting and Next-Day Planning</a:t>
-            </a:r>
-            <a:endParaRPr lang="en-US" sz="1400" dirty="0"/>
-          </a:p>
-        </p:txBody>
-      </p:sp>
-      <p:sp>
-        <p:nvSpPr>
-          <p:cNvPr id="21" name="Text 19"/>
-          <p:cNvSpPr/>
-          <p:nvPr/>
-        </p:nvSpPr>
-        <p:spPr>
-          <a:xfrm>
-            <a:off x="548640" y="6583680"/>
+              <a:t>Input: "Apple CEO Tim Cook said iPhone sales rose 20% last quarter."</a:t>
+            </a:r>
+            <a:endParaRPr lang="en-US" sz="1300" dirty="0"/>
+          </a:p>
+          <a:p>
+            <a:pPr indent="0" marL="0">
+              <a:buNone/>
+            </a:pPr>
+            <a:r>
+              <a:rPr lang="en-US" sz="1300" dirty="0">
+                <a:solidFill>
+                  <a:srgbClr val="1C2833"/>
+                </a:solidFill>
+              </a:rPr>
+              <a:t>Output: entities, key terms, grammatical roles, and normalized tokens ready for analysis.</a:t>
+            </a:r>
+            <a:endParaRPr lang="en-US" sz="1300" dirty="0"/>
+          </a:p>
+        </p:txBody>
+      </p:sp>
+      <p:sp>
+        <p:nvSpPr>
+          <p:cNvPr id="22" name="Text 20"/>
+          <p:cNvSpPr/>
+          <p:nvPr/>
+        </p:nvSpPr>
+        <p:spPr>
+          <a:xfrm>
+            <a:off x="548640" y="6537960"/>
             <a:ext cx="10972800" cy="274320"/>
           </a:xfrm>
           <a:prstGeom prst="rect">
@@ -3095,7 +2949,7 @@
                   <a:srgbClr val="9CA3AF"/>
                 </a:solidFill>
               </a:rPr>
-              <a:t>Office Presentation | 4</a:t>
+              <a:t>NLP Day 1 | 4</a:t>
             </a:r>
             <a:endParaRPr lang="en-US" sz="1000" dirty="0"/>
           </a:p>
@@ -3135,14 +2989,1305 @@
       </p:grpSpPr>
       <p:sp>
         <p:nvSpPr>
+          <p:cNvPr id="2" name="Shape 0"/>
+          <p:cNvSpPr/>
+          <p:nvPr/>
+        </p:nvSpPr>
+        <p:spPr>
+          <a:xfrm>
+            <a:off x="0" y="0"/>
+            <a:ext cx="12188952" cy="822960"/>
+          </a:xfrm>
+          <a:prstGeom prst="rect">
+            <a:avLst/>
+          </a:prstGeom>
+          <a:solidFill>
+            <a:srgbClr val="2C3E50"/>
+          </a:solidFill>
+          <a:ln w="12700">
+            <a:solidFill>
+              <a:srgbClr val="2C3E50"/>
+            </a:solidFill>
+            <a:prstDash val="solid"/>
+          </a:ln>
+        </p:spPr>
+      </p:sp>
+      <p:sp>
+        <p:nvSpPr>
+          <p:cNvPr id="3" name="Text 1"/>
+          <p:cNvSpPr/>
+          <p:nvPr/>
+        </p:nvSpPr>
+        <p:spPr>
+          <a:xfrm>
+            <a:off x="548640" y="201168"/>
+            <a:ext cx="9601200" cy="365760"/>
+          </a:xfrm>
+          <a:prstGeom prst="rect">
+            <a:avLst/>
+          </a:prstGeom>
+          <a:noFill/>
+          <a:ln/>
+        </p:spPr>
+        <p:txBody>
+          <a:bodyPr wrap="square" rtlCol="0" anchor="ctr"/>
+          <a:lstStyle/>
+          <a:p>
+            <a:pPr indent="0" marL="0">
+              <a:buNone/>
+            </a:pPr>
+            <a:r>
+              <a:rPr lang="en-US" sz="2000" b="1" dirty="0">
+                <a:solidFill>
+                  <a:srgbClr val="FFFFFF"/>
+                </a:solidFill>
+              </a:rPr>
+              <a:t>Tokenization and Stop Words</a:t>
+            </a:r>
+            <a:endParaRPr lang="en-US" sz="2000" dirty="0"/>
+          </a:p>
+        </p:txBody>
+      </p:sp>
+      <p:sp>
+        <p:nvSpPr>
+          <p:cNvPr id="4" name="Text 2"/>
+          <p:cNvSpPr/>
+          <p:nvPr/>
+        </p:nvSpPr>
+        <p:spPr>
+          <a:xfrm>
+            <a:off x="548640" y="914400"/>
+            <a:ext cx="10972800" cy="365760"/>
+          </a:xfrm>
+          <a:prstGeom prst="rect">
+            <a:avLst/>
+          </a:prstGeom>
+          <a:noFill/>
+          <a:ln/>
+        </p:spPr>
+        <p:txBody>
+          <a:bodyPr wrap="square" rtlCol="0" anchor="ctr"/>
+          <a:lstStyle/>
+          <a:p>
+            <a:pPr indent="0" marL="0">
+              <a:buNone/>
+            </a:pPr>
+            <a:r>
+              <a:rPr lang="en-US" sz="1300" dirty="0">
+                <a:solidFill>
+                  <a:srgbClr val="7F8C8D"/>
+                </a:solidFill>
+              </a:rPr>
+              <a:t>How text is split and filtered</a:t>
+            </a:r>
+            <a:endParaRPr lang="en-US" sz="1300" dirty="0"/>
+          </a:p>
+        </p:txBody>
+      </p:sp>
+      <p:sp>
+        <p:nvSpPr>
+          <p:cNvPr id="5" name="Text 3"/>
+          <p:cNvSpPr/>
+          <p:nvPr/>
+        </p:nvSpPr>
+        <p:spPr>
+          <a:xfrm>
+            <a:off x="822960" y="1463040"/>
+            <a:ext cx="4114800" cy="274320"/>
+          </a:xfrm>
+          <a:prstGeom prst="rect">
+            <a:avLst/>
+          </a:prstGeom>
+          <a:noFill/>
+          <a:ln/>
+        </p:spPr>
+        <p:txBody>
+          <a:bodyPr wrap="square" rtlCol="0" anchor="ctr"/>
+          <a:lstStyle/>
+          <a:p>
+            <a:pPr indent="0" marL="0">
+              <a:buNone/>
+            </a:pPr>
+            <a:r>
+              <a:rPr lang="en-US" sz="1500" b="1" dirty="0">
+                <a:solidFill>
+                  <a:srgbClr val="2C3E50"/>
+                </a:solidFill>
+              </a:rPr>
+              <a:t>Tokenization types:</a:t>
+            </a:r>
+            <a:endParaRPr lang="en-US" sz="1500" dirty="0"/>
+          </a:p>
+        </p:txBody>
+      </p:sp>
+      <p:sp>
+        <p:nvSpPr>
+          <p:cNvPr id="6" name="Text 4"/>
+          <p:cNvSpPr/>
+          <p:nvPr/>
+        </p:nvSpPr>
+        <p:spPr>
+          <a:xfrm>
+            <a:off x="914400" y="1828800"/>
+            <a:ext cx="5212080" cy="2377440"/>
+          </a:xfrm>
+          <a:prstGeom prst="rect">
+            <a:avLst/>
+          </a:prstGeom>
+          <a:noFill/>
+          <a:ln/>
+        </p:spPr>
+        <p:txBody>
+          <a:bodyPr wrap="square" rtlCol="0" anchor="ctr"/>
+          <a:lstStyle/>
+          <a:p>
+            <a:pPr marL="177800" indent="-177800">
+              <a:buSzPct val="100000"/>
+              <a:buChar char="•"/>
+            </a:pPr>
+            <a:r>
+              <a:rPr lang="en-US" sz="1300" dirty="0">
+                <a:solidFill>
+                  <a:srgbClr val="1C2833"/>
+                </a:solidFill>
+              </a:rPr>
+              <a:t>Word tokens: split by words and punctuation.</a:t>
+            </a:r>
+            <a:endParaRPr lang="en-US" sz="1300" dirty="0"/>
+          </a:p>
+          <a:p>
+            <a:pPr marL="177800" indent="-177800">
+              <a:buSzPct val="100000"/>
+              <a:buChar char="•"/>
+            </a:pPr>
+            <a:r>
+              <a:rPr lang="en-US" sz="1300" dirty="0">
+                <a:solidFill>
+                  <a:srgbClr val="1C2833"/>
+                </a:solidFill>
+              </a:rPr>
+              <a:t>Character tokens: every character as a token.</a:t>
+            </a:r>
+            <a:endParaRPr lang="en-US" sz="1300" dirty="0"/>
+          </a:p>
+          <a:p>
+            <a:pPr marL="177800" indent="-177800">
+              <a:buSzPct val="100000"/>
+              <a:buChar char="•"/>
+            </a:pPr>
+            <a:r>
+              <a:rPr lang="en-US" sz="1300" dirty="0">
+                <a:solidFill>
+                  <a:srgbClr val="1C2833"/>
+                </a:solidFill>
+              </a:rPr>
+              <a:t>Subword tokens: best for LLMs and unseen words.</a:t>
+            </a:r>
+            <a:endParaRPr lang="en-US" sz="1300" dirty="0"/>
+          </a:p>
+          <a:p>
+            <a:pPr marL="177800" indent="-177800">
+              <a:buSzPct val="100000"/>
+              <a:buChar char="•"/>
+            </a:pPr>
+            <a:r>
+              <a:rPr lang="en-US" sz="1300" dirty="0">
+                <a:solidFill>
+                  <a:srgbClr val="1C2833"/>
+                </a:solidFill>
+              </a:rPr>
+              <a:t>Sentence tokens: split by sentence boundaries.</a:t>
+            </a:r>
+            <a:endParaRPr lang="en-US" sz="1300" dirty="0"/>
+          </a:p>
+        </p:txBody>
+      </p:sp>
+      <p:sp>
+        <p:nvSpPr>
+          <p:cNvPr id="7" name="Shape 5"/>
+          <p:cNvSpPr/>
+          <p:nvPr/>
+        </p:nvSpPr>
+        <p:spPr>
+          <a:xfrm>
+            <a:off x="6217920" y="1463040"/>
+            <a:ext cx="5120640" cy="2834640"/>
+          </a:xfrm>
+          <a:prstGeom prst="roundRect">
+            <a:avLst/>
+          </a:prstGeom>
+          <a:solidFill>
+            <a:srgbClr val="FFFFFF"/>
+          </a:solidFill>
+          <a:ln w="12700">
+            <a:solidFill>
+              <a:srgbClr val="BDC3C7"/>
+            </a:solidFill>
+            <a:prstDash val="solid"/>
+          </a:ln>
+        </p:spPr>
+      </p:sp>
+      <p:sp>
+        <p:nvSpPr>
+          <p:cNvPr id="8" name="Text 6"/>
+          <p:cNvSpPr/>
+          <p:nvPr/>
+        </p:nvSpPr>
+        <p:spPr>
+          <a:xfrm>
+            <a:off x="6492240" y="1737360"/>
+            <a:ext cx="1645920" cy="274320"/>
+          </a:xfrm>
+          <a:prstGeom prst="rect">
+            <a:avLst/>
+          </a:prstGeom>
+          <a:noFill/>
+          <a:ln/>
+        </p:spPr>
+        <p:txBody>
+          <a:bodyPr wrap="square" rtlCol="0" anchor="ctr"/>
+          <a:lstStyle/>
+          <a:p>
+            <a:pPr indent="0" marL="0">
+              <a:buNone/>
+            </a:pPr>
+            <a:r>
+              <a:rPr lang="en-US" sz="1400" b="1" dirty="0">
+                <a:solidFill>
+                  <a:srgbClr val="5234B7"/>
+                </a:solidFill>
+              </a:rPr>
+              <a:t>Example</a:t>
+            </a:r>
+            <a:endParaRPr lang="en-US" sz="1400" dirty="0"/>
+          </a:p>
+        </p:txBody>
+      </p:sp>
+      <p:sp>
+        <p:nvSpPr>
+          <p:cNvPr id="9" name="Text 7"/>
+          <p:cNvSpPr/>
+          <p:nvPr/>
+        </p:nvSpPr>
+        <p:spPr>
+          <a:xfrm>
+            <a:off x="6492240" y="2103120"/>
+            <a:ext cx="4572000" cy="1737360"/>
+          </a:xfrm>
+          <a:prstGeom prst="rect">
+            <a:avLst/>
+          </a:prstGeom>
+          <a:noFill/>
+          <a:ln/>
+        </p:spPr>
+        <p:txBody>
+          <a:bodyPr wrap="square" rtlCol="0" anchor="ctr"/>
+          <a:lstStyle/>
+          <a:p>
+            <a:pPr indent="0" marL="0">
+              <a:buNone/>
+            </a:pPr>
+            <a:r>
+              <a:rPr lang="en-US" sz="1300" dirty="0">
+                <a:solidFill>
+                  <a:srgbClr val="1C2833"/>
+                </a:solidFill>
+              </a:rPr>
+              <a:t>Sentence: "This is the book that talks about artificial intelligence"</a:t>
+            </a:r>
+            <a:endParaRPr lang="en-US" sz="1300" dirty="0"/>
+          </a:p>
+          <a:p>
+            <a:pPr indent="0" marL="0">
+              <a:buNone/>
+            </a:pPr>
+            <a:r>
+              <a:rPr lang="en-US" sz="1300" dirty="0">
+                <a:solidFill>
+                  <a:srgbClr val="1C2833"/>
+                </a:solidFill>
+              </a:rPr>
+              <a:t>After stop-word reduction: "book talks artificial intelligence"</a:t>
+            </a:r>
+            <a:endParaRPr lang="en-US" sz="1300" dirty="0"/>
+          </a:p>
+        </p:txBody>
+      </p:sp>
+      <p:sp>
+        <p:nvSpPr>
+          <p:cNvPr id="10" name="Text 8"/>
+          <p:cNvSpPr/>
+          <p:nvPr/>
+        </p:nvSpPr>
+        <p:spPr>
+          <a:xfrm>
+            <a:off x="914400" y="4846320"/>
+            <a:ext cx="10607040" cy="822960"/>
+          </a:xfrm>
+          <a:prstGeom prst="rect">
+            <a:avLst/>
+          </a:prstGeom>
+          <a:noFill/>
+          <a:ln/>
+        </p:spPr>
+        <p:txBody>
+          <a:bodyPr wrap="square" rtlCol="0" anchor="ctr"/>
+          <a:lstStyle/>
+          <a:p>
+            <a:pPr indent="0" marL="0">
+              <a:buNone/>
+            </a:pPr>
+            <a:r>
+              <a:rPr lang="en-US" sz="1400" i="1" dirty="0">
+                <a:solidFill>
+                  <a:srgbClr val="E67E22"/>
+                </a:solidFill>
+              </a:rPr>
+              <a:t>Important: Do not remove stop words in tasks where meaning of words like "not" is critical.</a:t>
+            </a:r>
+            <a:endParaRPr lang="en-US" sz="1400" dirty="0"/>
+          </a:p>
+        </p:txBody>
+      </p:sp>
+      <p:sp>
+        <p:nvSpPr>
+          <p:cNvPr id="11" name="Text 9"/>
+          <p:cNvSpPr/>
+          <p:nvPr/>
+        </p:nvSpPr>
+        <p:spPr>
+          <a:xfrm>
+            <a:off x="548640" y="6537960"/>
+            <a:ext cx="10972800" cy="274320"/>
+          </a:xfrm>
+          <a:prstGeom prst="rect">
+            <a:avLst/>
+          </a:prstGeom>
+          <a:noFill/>
+          <a:ln/>
+        </p:spPr>
+        <p:txBody>
+          <a:bodyPr wrap="square" rtlCol="0" anchor="ctr"/>
+          <a:lstStyle/>
+          <a:p>
+            <a:pPr algn="r" indent="0" marL="0">
+              <a:buNone/>
+            </a:pPr>
+            <a:r>
+              <a:rPr lang="en-US" sz="1000" dirty="0">
+                <a:solidFill>
+                  <a:srgbClr val="9CA3AF"/>
+                </a:solidFill>
+              </a:rPr>
+              <a:t>NLP Day 1 | 5</a:t>
+            </a:r>
+            <a:endParaRPr lang="en-US" sz="1000" dirty="0"/>
+          </a:p>
+        </p:txBody>
+      </p:sp>
+    </p:spTree>
+  </p:cSld>
+  <p:clrMapOvr>
+    <a:masterClrMapping/>
+  </p:clrMapOvr>
+</p:sld>
+</file>
+
+<file path=ppt/slides/slide6.xml><?xml version="1.0" encoding="utf-8"?>
+<p:sld xmlns:a="http://schemas.openxmlformats.org/drawingml/2006/main" xmlns:r="http://schemas.openxmlformats.org/officeDocument/2006/relationships" xmlns:p="http://schemas.openxmlformats.org/presentationml/2006/main">
+  <p:cSld name="Slide 6">
+    <p:bg>
+      <p:bgPr>
+        <a:solidFill>
+          <a:srgbClr val="F3EEFF"/>
+        </a:solidFill>
+      </p:bgPr>
+    </p:bg>
+    <p:spTree>
+      <p:nvGrpSpPr>
+        <p:cNvPr id="1" name=""/>
+        <p:cNvGrpSpPr/>
+        <p:nvPr/>
+      </p:nvGrpSpPr>
+      <p:grpSpPr>
+        <a:xfrm>
+          <a:off x="0" y="0"/>
+          <a:ext cx="0" cy="0"/>
+          <a:chOff x="0" y="0"/>
+          <a:chExt cx="0" cy="0"/>
+        </a:xfrm>
+      </p:grpSpPr>
+      <p:sp>
+        <p:nvSpPr>
+          <p:cNvPr id="2" name="Shape 0"/>
+          <p:cNvSpPr/>
+          <p:nvPr/>
+        </p:nvSpPr>
+        <p:spPr>
+          <a:xfrm>
+            <a:off x="0" y="0"/>
+            <a:ext cx="12188952" cy="822960"/>
+          </a:xfrm>
+          <a:prstGeom prst="rect">
+            <a:avLst/>
+          </a:prstGeom>
+          <a:solidFill>
+            <a:srgbClr val="2C3E50"/>
+          </a:solidFill>
+          <a:ln w="12700">
+            <a:solidFill>
+              <a:srgbClr val="2C3E50"/>
+            </a:solidFill>
+            <a:prstDash val="solid"/>
+          </a:ln>
+        </p:spPr>
+      </p:sp>
+      <p:sp>
+        <p:nvSpPr>
+          <p:cNvPr id="3" name="Text 1"/>
+          <p:cNvSpPr/>
+          <p:nvPr/>
+        </p:nvSpPr>
+        <p:spPr>
+          <a:xfrm>
+            <a:off x="548640" y="201168"/>
+            <a:ext cx="9601200" cy="365760"/>
+          </a:xfrm>
+          <a:prstGeom prst="rect">
+            <a:avLst/>
+          </a:prstGeom>
+          <a:noFill/>
+          <a:ln/>
+        </p:spPr>
+        <p:txBody>
+          <a:bodyPr wrap="square" rtlCol="0" anchor="ctr"/>
+          <a:lstStyle/>
+          <a:p>
+            <a:pPr indent="0" marL="0">
+              <a:buNone/>
+            </a:pPr>
+            <a:r>
+              <a:rPr lang="en-US" sz="2000" b="1" dirty="0">
+                <a:solidFill>
+                  <a:srgbClr val="FFFFFF"/>
+                </a:solidFill>
+              </a:rPr>
+              <a:t>Stemming vs Lemmatization</a:t>
+            </a:r>
+            <a:endParaRPr lang="en-US" sz="2000" dirty="0"/>
+          </a:p>
+        </p:txBody>
+      </p:sp>
+      <p:sp>
+        <p:nvSpPr>
+          <p:cNvPr id="4" name="Text 2"/>
+          <p:cNvSpPr/>
+          <p:nvPr/>
+        </p:nvSpPr>
+        <p:spPr>
+          <a:xfrm>
+            <a:off x="548640" y="914400"/>
+            <a:ext cx="10972800" cy="365760"/>
+          </a:xfrm>
+          <a:prstGeom prst="rect">
+            <a:avLst/>
+          </a:prstGeom>
+          <a:noFill/>
+          <a:ln/>
+        </p:spPr>
+        <p:txBody>
+          <a:bodyPr wrap="square" rtlCol="0" anchor="ctr"/>
+          <a:lstStyle/>
+          <a:p>
+            <a:pPr indent="0" marL="0">
+              <a:buNone/>
+            </a:pPr>
+            <a:r>
+              <a:rPr lang="en-US" sz="1300" dirty="0">
+                <a:solidFill>
+                  <a:srgbClr val="7F8C8D"/>
+                </a:solidFill>
+              </a:rPr>
+              <a:t>Speed versus linguistic accuracy</a:t>
+            </a:r>
+            <a:endParaRPr lang="en-US" sz="1300" dirty="0"/>
+          </a:p>
+        </p:txBody>
+      </p:sp>
+      <p:sp>
+        <p:nvSpPr>
+          <p:cNvPr id="5" name="Shape 3"/>
+          <p:cNvSpPr/>
+          <p:nvPr/>
+        </p:nvSpPr>
+        <p:spPr>
+          <a:xfrm>
+            <a:off x="822960" y="1463040"/>
+            <a:ext cx="5303520" cy="3474720"/>
+          </a:xfrm>
+          <a:prstGeom prst="roundRect">
+            <a:avLst/>
+          </a:prstGeom>
+          <a:solidFill>
+            <a:srgbClr val="FFFFFF"/>
+          </a:solidFill>
+          <a:ln w="12700">
+            <a:solidFill>
+              <a:srgbClr val="BDC3C7"/>
+            </a:solidFill>
+            <a:prstDash val="solid"/>
+          </a:ln>
+        </p:spPr>
+      </p:sp>
+      <p:sp>
+        <p:nvSpPr>
+          <p:cNvPr id="6" name="Shape 4"/>
+          <p:cNvSpPr/>
+          <p:nvPr/>
+        </p:nvSpPr>
+        <p:spPr>
+          <a:xfrm>
+            <a:off x="6126480" y="1463040"/>
+            <a:ext cx="5303520" cy="3474720"/>
+          </a:xfrm>
+          <a:prstGeom prst="roundRect">
+            <a:avLst/>
+          </a:prstGeom>
+          <a:solidFill>
+            <a:srgbClr val="FFFFFF"/>
+          </a:solidFill>
+          <a:ln w="12700">
+            <a:solidFill>
+              <a:srgbClr val="BDC3C7"/>
+            </a:solidFill>
+            <a:prstDash val="solid"/>
+          </a:ln>
+        </p:spPr>
+      </p:sp>
+      <p:sp>
+        <p:nvSpPr>
+          <p:cNvPr id="7" name="Text 5"/>
+          <p:cNvSpPr/>
+          <p:nvPr/>
+        </p:nvSpPr>
+        <p:spPr>
+          <a:xfrm>
+            <a:off x="1097280" y="1783080"/>
+            <a:ext cx="2011680" cy="274320"/>
+          </a:xfrm>
+          <a:prstGeom prst="rect">
+            <a:avLst/>
+          </a:prstGeom>
+          <a:noFill/>
+          <a:ln/>
+        </p:spPr>
+        <p:txBody>
+          <a:bodyPr wrap="square" rtlCol="0" anchor="ctr"/>
+          <a:lstStyle/>
+          <a:p>
+            <a:pPr indent="0" marL="0">
+              <a:buNone/>
+            </a:pPr>
+            <a:r>
+              <a:rPr lang="en-US" sz="1600" b="1" dirty="0">
+                <a:solidFill>
+                  <a:srgbClr val="2C3E50"/>
+                </a:solidFill>
+              </a:rPr>
+              <a:t>Stemming</a:t>
+            </a:r>
+            <a:endParaRPr lang="en-US" sz="1600" dirty="0"/>
+          </a:p>
+        </p:txBody>
+      </p:sp>
+      <p:sp>
+        <p:nvSpPr>
+          <p:cNvPr id="8" name="Text 6"/>
+          <p:cNvSpPr/>
+          <p:nvPr/>
+        </p:nvSpPr>
+        <p:spPr>
+          <a:xfrm>
+            <a:off x="1097280" y="2148840"/>
+            <a:ext cx="4572000" cy="2377440"/>
+          </a:xfrm>
+          <a:prstGeom prst="rect">
+            <a:avLst/>
+          </a:prstGeom>
+          <a:noFill/>
+          <a:ln/>
+        </p:spPr>
+        <p:txBody>
+          <a:bodyPr wrap="square" rtlCol="0" anchor="ctr"/>
+          <a:lstStyle/>
+          <a:p>
+            <a:pPr marL="177800" indent="-177800">
+              <a:buSzPct val="100000"/>
+              <a:buChar char="•"/>
+            </a:pPr>
+            <a:r>
+              <a:rPr lang="en-US" sz="1300" dirty="0">
+                <a:solidFill>
+                  <a:srgbClr val="1C2833"/>
+                </a:solidFill>
+              </a:rPr>
+              <a:t>Rule-based truncation.</a:t>
+            </a:r>
+            <a:endParaRPr lang="en-US" sz="1300" dirty="0"/>
+          </a:p>
+          <a:p>
+            <a:pPr marL="177800" indent="-177800">
+              <a:buSzPct val="100000"/>
+              <a:buChar char="•"/>
+            </a:pPr>
+            <a:r>
+              <a:rPr lang="en-US" sz="1300" dirty="0">
+                <a:solidFill>
+                  <a:srgbClr val="1C2833"/>
+                </a:solidFill>
+              </a:rPr>
+              <a:t>Very fast.</a:t>
+            </a:r>
+            <a:endParaRPr lang="en-US" sz="1300" dirty="0"/>
+          </a:p>
+          <a:p>
+            <a:pPr marL="177800" indent="-177800">
+              <a:buSzPct val="100000"/>
+              <a:buChar char="•"/>
+            </a:pPr>
+            <a:r>
+              <a:rPr lang="en-US" sz="1300" dirty="0">
+                <a:solidFill>
+                  <a:srgbClr val="1C2833"/>
+                </a:solidFill>
+              </a:rPr>
+              <a:t>May output non-real words.</a:t>
+            </a:r>
+            <a:endParaRPr lang="en-US" sz="1300" dirty="0"/>
+          </a:p>
+          <a:p>
+            <a:pPr marL="177800" indent="-177800">
+              <a:buSzPct val="100000"/>
+              <a:buChar char="•"/>
+            </a:pPr>
+            <a:r>
+              <a:rPr lang="en-US" sz="1300" dirty="0">
+                <a:solidFill>
+                  <a:srgbClr val="1C2833"/>
+                </a:solidFill>
+              </a:rPr>
+              <a:t>Best for large-scale indexing.</a:t>
+            </a:r>
+            <a:endParaRPr lang="en-US" sz="1300" dirty="0"/>
+          </a:p>
+        </p:txBody>
+      </p:sp>
+      <p:sp>
+        <p:nvSpPr>
+          <p:cNvPr id="9" name="Text 7"/>
+          <p:cNvSpPr/>
+          <p:nvPr/>
+        </p:nvSpPr>
+        <p:spPr>
+          <a:xfrm>
+            <a:off x="6400800" y="1783080"/>
+            <a:ext cx="2926080" cy="274320"/>
+          </a:xfrm>
+          <a:prstGeom prst="rect">
+            <a:avLst/>
+          </a:prstGeom>
+          <a:noFill/>
+          <a:ln/>
+        </p:spPr>
+        <p:txBody>
+          <a:bodyPr wrap="square" rtlCol="0" anchor="ctr"/>
+          <a:lstStyle/>
+          <a:p>
+            <a:pPr indent="0" marL="0">
+              <a:buNone/>
+            </a:pPr>
+            <a:r>
+              <a:rPr lang="en-US" sz="1600" b="1" dirty="0">
+                <a:solidFill>
+                  <a:srgbClr val="5234B7"/>
+                </a:solidFill>
+              </a:rPr>
+              <a:t>Lemmatization</a:t>
+            </a:r>
+            <a:endParaRPr lang="en-US" sz="1600" dirty="0"/>
+          </a:p>
+        </p:txBody>
+      </p:sp>
+      <p:sp>
+        <p:nvSpPr>
+          <p:cNvPr id="10" name="Text 8"/>
+          <p:cNvSpPr/>
+          <p:nvPr/>
+        </p:nvSpPr>
+        <p:spPr>
+          <a:xfrm>
+            <a:off x="6400800" y="2148840"/>
+            <a:ext cx="4572000" cy="2377440"/>
+          </a:xfrm>
+          <a:prstGeom prst="rect">
+            <a:avLst/>
+          </a:prstGeom>
+          <a:noFill/>
+          <a:ln/>
+        </p:spPr>
+        <p:txBody>
+          <a:bodyPr wrap="square" rtlCol="0" anchor="ctr"/>
+          <a:lstStyle/>
+          <a:p>
+            <a:pPr marL="177800" indent="-177800">
+              <a:buSzPct val="100000"/>
+              <a:buChar char="•"/>
+            </a:pPr>
+            <a:r>
+              <a:rPr lang="en-US" sz="1300" dirty="0">
+                <a:solidFill>
+                  <a:srgbClr val="1C2833"/>
+                </a:solidFill>
+              </a:rPr>
+              <a:t>Dictionary and grammar aware.</a:t>
+            </a:r>
+            <a:endParaRPr lang="en-US" sz="1300" dirty="0"/>
+          </a:p>
+          <a:p>
+            <a:pPr marL="177800" indent="-177800">
+              <a:buSzPct val="100000"/>
+              <a:buChar char="•"/>
+            </a:pPr>
+            <a:r>
+              <a:rPr lang="en-US" sz="1300" dirty="0">
+                <a:solidFill>
+                  <a:srgbClr val="1C2833"/>
+                </a:solidFill>
+              </a:rPr>
+              <a:t>More accurate, slightly slower.</a:t>
+            </a:r>
+            <a:endParaRPr lang="en-US" sz="1300" dirty="0"/>
+          </a:p>
+          <a:p>
+            <a:pPr marL="177800" indent="-177800">
+              <a:buSzPct val="100000"/>
+              <a:buChar char="•"/>
+            </a:pPr>
+            <a:r>
+              <a:rPr lang="en-US" sz="1300" dirty="0">
+                <a:solidFill>
+                  <a:srgbClr val="1C2833"/>
+                </a:solidFill>
+              </a:rPr>
+              <a:t>Outputs valid base forms.</a:t>
+            </a:r>
+            <a:endParaRPr lang="en-US" sz="1300" dirty="0"/>
+          </a:p>
+          <a:p>
+            <a:pPr marL="177800" indent="-177800">
+              <a:buSzPct val="100000"/>
+              <a:buChar char="•"/>
+            </a:pPr>
+            <a:r>
+              <a:rPr lang="en-US" sz="1300" dirty="0">
+                <a:solidFill>
+                  <a:srgbClr val="1C2833"/>
+                </a:solidFill>
+              </a:rPr>
+              <a:t>Best for chatbots and QA tasks.</a:t>
+            </a:r>
+            <a:endParaRPr lang="en-US" sz="1300" dirty="0"/>
+          </a:p>
+        </p:txBody>
+      </p:sp>
+      <p:sp>
+        <p:nvSpPr>
+          <p:cNvPr id="11" name="Text 9"/>
+          <p:cNvSpPr/>
+          <p:nvPr/>
+        </p:nvSpPr>
+        <p:spPr>
+          <a:xfrm>
+            <a:off x="914400" y="5303520"/>
+            <a:ext cx="10607040" cy="457200"/>
+          </a:xfrm>
+          <a:prstGeom prst="rect">
+            <a:avLst/>
+          </a:prstGeom>
+          <a:noFill/>
+          <a:ln/>
+        </p:spPr>
+        <p:txBody>
+          <a:bodyPr wrap="square" rtlCol="0" anchor="ctr"/>
+          <a:lstStyle/>
+          <a:p>
+            <a:pPr indent="0" marL="0">
+              <a:buNone/>
+            </a:pPr>
+            <a:r>
+              <a:rPr lang="en-US" sz="1400" i="1" dirty="0">
+                <a:solidFill>
+                  <a:srgbClr val="E67E22"/>
+                </a:solidFill>
+              </a:rPr>
+              <a:t>Examples: studies -&gt; study, mice -&gt; mouse, better -&gt; good</a:t>
+            </a:r>
+            <a:endParaRPr lang="en-US" sz="1400" dirty="0"/>
+          </a:p>
+        </p:txBody>
+      </p:sp>
+      <p:sp>
+        <p:nvSpPr>
+          <p:cNvPr id="12" name="Text 10"/>
+          <p:cNvSpPr/>
+          <p:nvPr/>
+        </p:nvSpPr>
+        <p:spPr>
+          <a:xfrm>
+            <a:off x="548640" y="6537960"/>
+            <a:ext cx="10972800" cy="274320"/>
+          </a:xfrm>
+          <a:prstGeom prst="rect">
+            <a:avLst/>
+          </a:prstGeom>
+          <a:noFill/>
+          <a:ln/>
+        </p:spPr>
+        <p:txBody>
+          <a:bodyPr wrap="square" rtlCol="0" anchor="ctr"/>
+          <a:lstStyle/>
+          <a:p>
+            <a:pPr algn="r" indent="0" marL="0">
+              <a:buNone/>
+            </a:pPr>
+            <a:r>
+              <a:rPr lang="en-US" sz="1000" dirty="0">
+                <a:solidFill>
+                  <a:srgbClr val="9CA3AF"/>
+                </a:solidFill>
+              </a:rPr>
+              <a:t>NLP Day 1 | 6</a:t>
+            </a:r>
+            <a:endParaRPr lang="en-US" sz="1000" dirty="0"/>
+          </a:p>
+        </p:txBody>
+      </p:sp>
+    </p:spTree>
+  </p:cSld>
+  <p:clrMapOvr>
+    <a:masterClrMapping/>
+  </p:clrMapOvr>
+</p:sld>
+</file>
+
+<file path=ppt/slides/slide7.xml><?xml version="1.0" encoding="utf-8"?>
+<p:sld xmlns:a="http://schemas.openxmlformats.org/drawingml/2006/main" xmlns:r="http://schemas.openxmlformats.org/officeDocument/2006/relationships" xmlns:p="http://schemas.openxmlformats.org/presentationml/2006/main">
+  <p:cSld name="Slide 7">
+    <p:bg>
+      <p:bgPr>
+        <a:solidFill>
+          <a:srgbClr val="F3EEFF"/>
+        </a:solidFill>
+      </p:bgPr>
+    </p:bg>
+    <p:spTree>
+      <p:nvGrpSpPr>
+        <p:cNvPr id="1" name=""/>
+        <p:cNvGrpSpPr/>
+        <p:nvPr/>
+      </p:nvGrpSpPr>
+      <p:grpSpPr>
+        <a:xfrm>
+          <a:off x="0" y="0"/>
+          <a:ext cx="0" cy="0"/>
+          <a:chOff x="0" y="0"/>
+          <a:chExt cx="0" cy="0"/>
+        </a:xfrm>
+      </p:grpSpPr>
+      <p:sp>
+        <p:nvSpPr>
+          <p:cNvPr id="2" name="Shape 0"/>
+          <p:cNvSpPr/>
+          <p:nvPr/>
+        </p:nvSpPr>
+        <p:spPr>
+          <a:xfrm>
+            <a:off x="0" y="0"/>
+            <a:ext cx="12188952" cy="822960"/>
+          </a:xfrm>
+          <a:prstGeom prst="rect">
+            <a:avLst/>
+          </a:prstGeom>
+          <a:solidFill>
+            <a:srgbClr val="2C3E50"/>
+          </a:solidFill>
+          <a:ln w="12700">
+            <a:solidFill>
+              <a:srgbClr val="2C3E50"/>
+            </a:solidFill>
+            <a:prstDash val="solid"/>
+          </a:ln>
+        </p:spPr>
+      </p:sp>
+      <p:sp>
+        <p:nvSpPr>
+          <p:cNvPr id="3" name="Text 1"/>
+          <p:cNvSpPr/>
+          <p:nvPr/>
+        </p:nvSpPr>
+        <p:spPr>
+          <a:xfrm>
+            <a:off x="548640" y="201168"/>
+            <a:ext cx="9601200" cy="365760"/>
+          </a:xfrm>
+          <a:prstGeom prst="rect">
+            <a:avLst/>
+          </a:prstGeom>
+          <a:noFill/>
+          <a:ln/>
+        </p:spPr>
+        <p:txBody>
+          <a:bodyPr wrap="square" rtlCol="0" anchor="ctr"/>
+          <a:lstStyle/>
+          <a:p>
+            <a:pPr indent="0" marL="0">
+              <a:buNone/>
+            </a:pPr>
+            <a:r>
+              <a:rPr lang="en-US" sz="2000" b="1" dirty="0">
+                <a:solidFill>
+                  <a:srgbClr val="FFFFFF"/>
+                </a:solidFill>
+              </a:rPr>
+              <a:t>POS Tagging and Named Entity Recognition</a:t>
+            </a:r>
+            <a:endParaRPr lang="en-US" sz="2000" dirty="0"/>
+          </a:p>
+        </p:txBody>
+      </p:sp>
+      <p:sp>
+        <p:nvSpPr>
+          <p:cNvPr id="4" name="Text 2"/>
+          <p:cNvSpPr/>
+          <p:nvPr/>
+        </p:nvSpPr>
+        <p:spPr>
+          <a:xfrm>
+            <a:off x="548640" y="914400"/>
+            <a:ext cx="10972800" cy="365760"/>
+          </a:xfrm>
+          <a:prstGeom prst="rect">
+            <a:avLst/>
+          </a:prstGeom>
+          <a:noFill/>
+          <a:ln/>
+        </p:spPr>
+        <p:txBody>
+          <a:bodyPr wrap="square" rtlCol="0" anchor="ctr"/>
+          <a:lstStyle/>
+          <a:p>
+            <a:pPr indent="0" marL="0">
+              <a:buNone/>
+            </a:pPr>
+            <a:r>
+              <a:rPr lang="en-US" sz="1300" dirty="0">
+                <a:solidFill>
+                  <a:srgbClr val="7F8C8D"/>
+                </a:solidFill>
+              </a:rPr>
+              <a:t>Understanding grammar and extracting facts</a:t>
+            </a:r>
+            <a:endParaRPr lang="en-US" sz="1300" dirty="0"/>
+          </a:p>
+        </p:txBody>
+      </p:sp>
+      <p:sp>
+        <p:nvSpPr>
+          <p:cNvPr id="5" name="Text 3"/>
+          <p:cNvSpPr/>
+          <p:nvPr/>
+        </p:nvSpPr>
+        <p:spPr>
+          <a:xfrm>
+            <a:off x="822960" y="1554480"/>
+            <a:ext cx="10789920" cy="411480"/>
+          </a:xfrm>
+          <a:prstGeom prst="rect">
+            <a:avLst/>
+          </a:prstGeom>
+          <a:noFill/>
+          <a:ln/>
+        </p:spPr>
+        <p:txBody>
+          <a:bodyPr wrap="square" rtlCol="0" anchor="ctr"/>
+          <a:lstStyle/>
+          <a:p>
+            <a:pPr indent="0" marL="0">
+              <a:buNone/>
+            </a:pPr>
+            <a:r>
+              <a:rPr lang="en-US" sz="1400" dirty="0">
+                <a:solidFill>
+                  <a:srgbClr val="1C2833"/>
+                </a:solidFill>
+              </a:rPr>
+              <a:t>POS Tagging labels each word by grammatical role (NOUN, VERB, ADJ, etc.).</a:t>
+            </a:r>
+            <a:endParaRPr lang="en-US" sz="1400" dirty="0"/>
+          </a:p>
+        </p:txBody>
+      </p:sp>
+      <p:sp>
+        <p:nvSpPr>
+          <p:cNvPr id="6" name="Text 4"/>
+          <p:cNvSpPr/>
+          <p:nvPr/>
+        </p:nvSpPr>
+        <p:spPr>
+          <a:xfrm>
+            <a:off x="822960" y="2011680"/>
+            <a:ext cx="10789920" cy="411480"/>
+          </a:xfrm>
+          <a:prstGeom prst="rect">
+            <a:avLst/>
+          </a:prstGeom>
+          <a:noFill/>
+          <a:ln/>
+        </p:spPr>
+        <p:txBody>
+          <a:bodyPr wrap="square" rtlCol="0" anchor="ctr"/>
+          <a:lstStyle/>
+          <a:p>
+            <a:pPr indent="0" marL="0">
+              <a:buNone/>
+            </a:pPr>
+            <a:r>
+              <a:rPr lang="en-US" sz="1400" dirty="0">
+                <a:solidFill>
+                  <a:srgbClr val="1C2833"/>
+                </a:solidFill>
+              </a:rPr>
+              <a:t>NER identifies entities like PERSON, ORG, DATE, MONEY, and LOCATION.</a:t>
+            </a:r>
+            <a:endParaRPr lang="en-US" sz="1400" dirty="0"/>
+          </a:p>
+        </p:txBody>
+      </p:sp>
+      <p:sp>
+        <p:nvSpPr>
+          <p:cNvPr id="7" name="Shape 5"/>
+          <p:cNvSpPr/>
+          <p:nvPr/>
+        </p:nvSpPr>
+        <p:spPr>
+          <a:xfrm>
+            <a:off x="822960" y="2651760"/>
+            <a:ext cx="10789920" cy="2468880"/>
+          </a:xfrm>
+          <a:prstGeom prst="roundRect">
+            <a:avLst/>
+          </a:prstGeom>
+          <a:solidFill>
+            <a:srgbClr val="FFFFFF"/>
+          </a:solidFill>
+          <a:ln w="12700">
+            <a:solidFill>
+              <a:srgbClr val="BDC3C7"/>
+            </a:solidFill>
+            <a:prstDash val="solid"/>
+          </a:ln>
+        </p:spPr>
+      </p:sp>
+      <p:sp>
+        <p:nvSpPr>
+          <p:cNvPr id="8" name="Text 6"/>
+          <p:cNvSpPr/>
+          <p:nvPr/>
+        </p:nvSpPr>
+        <p:spPr>
+          <a:xfrm>
+            <a:off x="1097280" y="2926080"/>
+            <a:ext cx="10149840" cy="2011680"/>
+          </a:xfrm>
+          <a:prstGeom prst="rect">
+            <a:avLst/>
+          </a:prstGeom>
+          <a:noFill/>
+          <a:ln/>
+        </p:spPr>
+        <p:txBody>
+          <a:bodyPr wrap="square" rtlCol="0" anchor="ctr"/>
+          <a:lstStyle/>
+          <a:p>
+            <a:pPr indent="0" marL="0">
+              <a:buNone/>
+            </a:pPr>
+            <a:r>
+              <a:rPr lang="en-US" sz="1300" dirty="0">
+                <a:solidFill>
+                  <a:srgbClr val="5234B7"/>
+                </a:solidFill>
+              </a:rPr>
+              <a:t>Example sentence: "Apple CEO Tim Cook announced a $430 billion investment in the United States."</a:t>
+            </a:r>
+            <a:endParaRPr lang="en-US" sz="1300" dirty="0"/>
+          </a:p>
+          <a:p>
+            <a:pPr indent="0" marL="0">
+              <a:buNone/>
+            </a:pPr>
+            <a:endParaRPr lang="en-US" sz="1300" dirty="0"/>
+          </a:p>
+          <a:p>
+            <a:pPr indent="0" marL="0">
+              <a:buNone/>
+            </a:pPr>
+            <a:r>
+              <a:rPr lang="en-US" sz="1300" dirty="0">
+                <a:solidFill>
+                  <a:srgbClr val="5234B7"/>
+                </a:solidFill>
+              </a:rPr>
+              <a:t>Possible extracted entities:</a:t>
+            </a:r>
+            <a:endParaRPr lang="en-US" sz="1300" dirty="0"/>
+          </a:p>
+          <a:p>
+            <a:pPr indent="0" marL="0">
+              <a:buNone/>
+            </a:pPr>
+            <a:r>
+              <a:rPr lang="en-US" sz="1300" dirty="0">
+                <a:solidFill>
+                  <a:srgbClr val="5234B7"/>
+                </a:solidFill>
+              </a:rPr>
+              <a:t>- ORG: Apple</a:t>
+            </a:r>
+            <a:endParaRPr lang="en-US" sz="1300" dirty="0"/>
+          </a:p>
+          <a:p>
+            <a:pPr indent="0" marL="0">
+              <a:buNone/>
+            </a:pPr>
+            <a:r>
+              <a:rPr lang="en-US" sz="1300" dirty="0">
+                <a:solidFill>
+                  <a:srgbClr val="5234B7"/>
+                </a:solidFill>
+              </a:rPr>
+              <a:t>- PERSON: Tim Cook</a:t>
+            </a:r>
+            <a:endParaRPr lang="en-US" sz="1300" dirty="0"/>
+          </a:p>
+          <a:p>
+            <a:pPr indent="0" marL="0">
+              <a:buNone/>
+            </a:pPr>
+            <a:r>
+              <a:rPr lang="en-US" sz="1300" dirty="0">
+                <a:solidFill>
+                  <a:srgbClr val="5234B7"/>
+                </a:solidFill>
+              </a:rPr>
+              <a:t>- MONEY: $430 billion</a:t>
+            </a:r>
+            <a:endParaRPr lang="en-US" sz="1300" dirty="0"/>
+          </a:p>
+          <a:p>
+            <a:pPr indent="0" marL="0">
+              <a:buNone/>
+            </a:pPr>
+            <a:r>
+              <a:rPr lang="en-US" sz="1300" dirty="0">
+                <a:solidFill>
+                  <a:srgbClr val="5234B7"/>
+                </a:solidFill>
+              </a:rPr>
+              <a:t>- GPE: United States</a:t>
+            </a:r>
+            <a:endParaRPr lang="en-US" sz="1300" dirty="0"/>
+          </a:p>
+        </p:txBody>
+      </p:sp>
+      <p:sp>
+        <p:nvSpPr>
+          <p:cNvPr id="9" name="Text 7"/>
+          <p:cNvSpPr/>
+          <p:nvPr/>
+        </p:nvSpPr>
+        <p:spPr>
+          <a:xfrm>
+            <a:off x="548640" y="6537960"/>
+            <a:ext cx="10972800" cy="274320"/>
+          </a:xfrm>
+          <a:prstGeom prst="rect">
+            <a:avLst/>
+          </a:prstGeom>
+          <a:noFill/>
+          <a:ln/>
+        </p:spPr>
+        <p:txBody>
+          <a:bodyPr wrap="square" rtlCol="0" anchor="ctr"/>
+          <a:lstStyle/>
+          <a:p>
+            <a:pPr algn="r" indent="0" marL="0">
+              <a:buNone/>
+            </a:pPr>
+            <a:r>
+              <a:rPr lang="en-US" sz="1000" dirty="0">
+                <a:solidFill>
+                  <a:srgbClr val="9CA3AF"/>
+                </a:solidFill>
+              </a:rPr>
+              <a:t>NLP Day 1 | 7</a:t>
+            </a:r>
+            <a:endParaRPr lang="en-US" sz="1000" dirty="0"/>
+          </a:p>
+        </p:txBody>
+      </p:sp>
+    </p:spTree>
+  </p:cSld>
+  <p:clrMapOvr>
+    <a:masterClrMapping/>
+  </p:clrMapOvr>
+</p:sld>
+</file>
+
+<file path=ppt/slides/slide8.xml><?xml version="1.0" encoding="utf-8"?>
+<p:sld xmlns:a="http://schemas.openxmlformats.org/drawingml/2006/main" xmlns:r="http://schemas.openxmlformats.org/officeDocument/2006/relationships" xmlns:p="http://schemas.openxmlformats.org/presentationml/2006/main">
+  <p:cSld name="Slide 8">
+    <p:bg>
+      <p:bgPr>
+        <a:solidFill>
+          <a:srgbClr val="F3EEFF"/>
+        </a:solidFill>
+      </p:bgPr>
+    </p:bg>
+    <p:spTree>
+      <p:nvGrpSpPr>
+        <p:cNvPr id="1" name=""/>
+        <p:cNvGrpSpPr/>
+        <p:nvPr/>
+      </p:nvGrpSpPr>
+      <p:grpSpPr>
+        <a:xfrm>
+          <a:off x="0" y="0"/>
+          <a:ext cx="0" cy="0"/>
+          <a:chOff x="0" y="0"/>
+          <a:chExt cx="0" cy="0"/>
+        </a:xfrm>
+      </p:grpSpPr>
+      <p:sp>
+        <p:nvSpPr>
           <p:cNvPr id="2" name="Text 0"/>
           <p:cNvSpPr/>
           <p:nvPr/>
         </p:nvSpPr>
         <p:spPr>
           <a:xfrm>
-            <a:off x="731520" y="2011680"/>
-            <a:ext cx="10789920" cy="822960"/>
+            <a:off x="731520" y="1188720"/>
+            <a:ext cx="10789920" cy="731520"/>
           </a:xfrm>
           <a:prstGeom prst="rect">
             <a:avLst/>
@@ -3158,14 +4303,14 @@
               <a:buNone/>
             </a:pPr>
             <a:r>
-              <a:rPr lang="en-US" sz="4400" b="1" dirty="0">
+              <a:rPr lang="en-US" sz="3800" b="1" dirty="0">
                 <a:solidFill>
                   <a:srgbClr val="2C3E50"/>
                 </a:solidFill>
               </a:rPr>
-              <a:t>Thank You</a:t>
-            </a:r>
-            <a:endParaRPr lang="en-US" sz="4400" dirty="0"/>
+              <a:t>Day 1 Summary</a:t>
+            </a:r>
+            <a:endParaRPr lang="en-US" sz="3800" dirty="0"/>
           </a:p>
         </p:txBody>
       </p:sp>
@@ -3177,80 +4322,90 @@
         </p:nvSpPr>
         <p:spPr>
           <a:xfrm>
-            <a:off x="1097280" y="3017520"/>
-            <a:ext cx="10058400" cy="457200"/>
-          </a:xfrm>
-          <a:prstGeom prst="rect">
-            <a:avLst/>
-          </a:prstGeom>
-          <a:noFill/>
-          <a:ln/>
-        </p:spPr>
-        <p:txBody>
-          <a:bodyPr wrap="square" rtlCol="0" anchor="ctr"/>
-          <a:lstStyle/>
-          <a:p>
-            <a:pPr algn="ctr" indent="0" marL="0">
-              <a:buNone/>
-            </a:pPr>
-            <a:r>
-              <a:rPr lang="en-US" sz="1900" dirty="0">
+            <a:off x="1097280" y="2194560"/>
+            <a:ext cx="9966960" cy="2377440"/>
+          </a:xfrm>
+          <a:prstGeom prst="rect">
+            <a:avLst/>
+          </a:prstGeom>
+          <a:noFill/>
+          <a:ln/>
+        </p:spPr>
+        <p:txBody>
+          <a:bodyPr wrap="square" rtlCol="0" anchor="ctr"/>
+          <a:lstStyle/>
+          <a:p>
+            <a:pPr marL="177800" indent="-177800">
+              <a:buSzPct val="100000"/>
+              <a:buChar char="•"/>
+            </a:pPr>
+            <a:r>
+              <a:rPr lang="en-US" sz="1600" dirty="0">
                 <a:solidFill>
                   <a:srgbClr val="1C2833"/>
                 </a:solidFill>
               </a:rPr>
-              <a:t>We look forward to achieving great results together.</a:t>
-            </a:r>
-            <a:endParaRPr lang="en-US" sz="1900" dirty="0"/>
-          </a:p>
-        </p:txBody>
-      </p:sp>
-      <p:sp>
-        <p:nvSpPr>
-          <p:cNvPr id="4" name="Text 2"/>
-          <p:cNvSpPr/>
-          <p:nvPr/>
-        </p:nvSpPr>
-        <p:spPr>
-          <a:xfrm>
-            <a:off x="1097280" y="3840480"/>
-            <a:ext cx="10058400" cy="365760"/>
-          </a:xfrm>
-          <a:prstGeom prst="rect">
-            <a:avLst/>
-          </a:prstGeom>
-          <a:noFill/>
-          <a:ln/>
-        </p:spPr>
-        <p:txBody>
-          <a:bodyPr wrap="square" rtlCol="0" anchor="ctr"/>
-          <a:lstStyle/>
-          <a:p>
-            <a:pPr algn="ctr" indent="0" marL="0">
-              <a:buNone/>
-            </a:pPr>
-            <a:r>
-              <a:rPr lang="en-US" sz="1400" dirty="0">
-                <a:solidFill>
-                  <a:srgbClr val="7F8C8D"/>
-                </a:solidFill>
-              </a:rPr>
-              <a:t>Contact: office@example.com</a:t>
-            </a:r>
-            <a:endParaRPr lang="en-US" sz="1400" dirty="0"/>
-          </a:p>
-        </p:txBody>
-      </p:sp>
-      <p:sp>
-        <p:nvSpPr>
-          <p:cNvPr id="5" name="Shape 3"/>
-          <p:cNvSpPr/>
-          <p:nvPr/>
-        </p:nvSpPr>
-        <p:spPr>
-          <a:xfrm>
-            <a:off x="4663440" y="4389120"/>
-            <a:ext cx="2834640" cy="411480"/>
+              <a:t>NLP is about converting language into structured, machine-usable information.</a:t>
+            </a:r>
+            <a:endParaRPr lang="en-US" sz="1600" dirty="0"/>
+          </a:p>
+          <a:p>
+            <a:pPr marL="177800" indent="-177800">
+              <a:buSzPct val="100000"/>
+              <a:buChar char="•"/>
+            </a:pPr>
+            <a:r>
+              <a:rPr lang="en-US" sz="1600" dirty="0">
+                <a:solidFill>
+                  <a:srgbClr val="1C2833"/>
+                </a:solidFill>
+              </a:rPr>
+              <a:t>The pipeline starts with cleaning and ends with rich linguistic features.</a:t>
+            </a:r>
+            <a:endParaRPr lang="en-US" sz="1600" dirty="0"/>
+          </a:p>
+          <a:p>
+            <a:pPr marL="177800" indent="-177800">
+              <a:buSzPct val="100000"/>
+              <a:buChar char="•"/>
+            </a:pPr>
+            <a:r>
+              <a:rPr lang="en-US" sz="1600" dirty="0">
+                <a:solidFill>
+                  <a:srgbClr val="1C2833"/>
+                </a:solidFill>
+              </a:rPr>
+              <a:t>Tokenization, lemmatization, POS, and NER are foundational building blocks.</a:t>
+            </a:r>
+            <a:endParaRPr lang="en-US" sz="1600" dirty="0"/>
+          </a:p>
+          <a:p>
+            <a:pPr marL="177800" indent="-177800">
+              <a:buSzPct val="100000"/>
+              <a:buChar char="•"/>
+            </a:pPr>
+            <a:r>
+              <a:rPr lang="en-US" sz="1600" dirty="0">
+                <a:solidFill>
+                  <a:srgbClr val="1C2833"/>
+                </a:solidFill>
+              </a:rPr>
+              <a:t>Choosing the right preprocessing depends on the target task and quality needs.</a:t>
+            </a:r>
+            <a:endParaRPr lang="en-US" sz="1600" dirty="0"/>
+          </a:p>
+        </p:txBody>
+      </p:sp>
+      <p:sp>
+        <p:nvSpPr>
+          <p:cNvPr id="4" name="Shape 2"/>
+          <p:cNvSpPr/>
+          <p:nvPr/>
+        </p:nvSpPr>
+        <p:spPr>
+          <a:xfrm>
+            <a:off x="4206240" y="5029200"/>
+            <a:ext cx="3749040" cy="685800"/>
           </a:xfrm>
           <a:prstGeom prst="roundRect">
             <a:avLst/>
@@ -3268,14 +4423,14 @@
       </p:sp>
       <p:sp>
         <p:nvSpPr>
-          <p:cNvPr id="6" name="Text 4"/>
-          <p:cNvSpPr/>
-          <p:nvPr/>
-        </p:nvSpPr>
-        <p:spPr>
-          <a:xfrm>
-            <a:off x="4663440" y="4480560"/>
-            <a:ext cx="2834640" cy="182880"/>
+          <p:cNvPr id="5" name="Text 3"/>
+          <p:cNvSpPr/>
+          <p:nvPr/>
+        </p:nvSpPr>
+        <p:spPr>
+          <a:xfrm>
+            <a:off x="4206240" y="5257800"/>
+            <a:ext cx="3749040" cy="274320"/>
           </a:xfrm>
           <a:prstGeom prst="rect">
             <a:avLst/>
@@ -3291,14 +4446,14 @@
               <a:buNone/>
             </a:pPr>
             <a:r>
-              <a:rPr lang="en-US" sz="1200" b="1" dirty="0">
+              <a:rPr lang="en-US" sz="1400" b="1" dirty="0">
                 <a:solidFill>
                   <a:srgbClr val="FFFFFF"/>
                 </a:solidFill>
               </a:rPr>
-              <a:t>Let's Build Success</a:t>
-            </a:r>
-            <a:endParaRPr lang="en-US" sz="1200" dirty="0"/>
+              <a:t>Next: Text Representations</a:t>
+            </a:r>
+            <a:endParaRPr lang="en-US" sz="1400" dirty="0"/>
           </a:p>
         </p:txBody>
       </p:sp>

</xml_diff>